<commit_message>
docs: actualizar presentación final
</commit_message>
<xml_diff>
--- a/presentation/Cinco variaciones modernas del diagrama de caja y bigotes.pptx
+++ b/presentation/Cinco variaciones modernas del diagrama de caja y bigotes.pptx
@@ -71,18 +71,19 @@
             <a:noAutofit/>
           </a:bodyPr>
           <a:p>
-            <a:r>
-              <a:rPr b="0" lang="es-ES" sz="1800" spc="-1" strike="noStrike">
-                <a:solidFill>
-                  <a:schemeClr val="dk1"/>
+            <a:pPr algn="ctr"/>
+            <a:r>
+              <a:rPr b="0" lang="es-ES" sz="4400" spc="-1" strike="noStrike">
+                <a:solidFill>
+                  <a:srgbClr val="000000"/>
                 </a:solidFill>
                 <a:latin typeface="Arial"/>
               </a:rPr>
               <a:t>Pulse para desplazar la diapositiva</a:t>
             </a:r>
-            <a:endParaRPr b="0" lang="es-ES" sz="1800" spc="-1" strike="noStrike">
-              <a:solidFill>
-                <a:schemeClr val="dk1"/>
+            <a:endParaRPr b="0" lang="es-ES" sz="4400" spc="-1" strike="noStrike">
+              <a:solidFill>
+                <a:srgbClr val="000000"/>
               </a:solidFill>
               <a:latin typeface="Arial"/>
             </a:endParaRPr>
@@ -349,7 +350,7 @@
             <a:pPr indent="0" algn="r">
               <a:buNone/>
             </a:pPr>
-            <a:fld id="{FD17E389-F0F1-4FC0-A9FB-87B8716F132A}" type="slidenum">
+            <a:fld id="{010BAE3C-A856-4388-B311-B890D51F1856}" type="slidenum">
               <a:rPr b="0" lang="es-ES" sz="1400" spc="-1" strike="noStrike">
                 <a:solidFill>
                   <a:srgbClr val="000000"/>
@@ -403,7 +404,7 @@
         <p:spPr>
           <a:xfrm>
             <a:off x="685800" y="1143000"/>
-            <a:ext cx="5486040" cy="3085920"/>
+            <a:ext cx="5484960" cy="3084840"/>
           </a:xfrm>
           <a:prstGeom prst="rect">
             <a:avLst/>
@@ -426,7 +427,7 @@
         <p:spPr>
           <a:xfrm>
             <a:off x="685800" y="4400640"/>
-            <a:ext cx="5486040" cy="3600000"/>
+            <a:ext cx="5484960" cy="3598920"/>
           </a:xfrm>
           <a:prstGeom prst="rect">
             <a:avLst/>
@@ -446,9 +447,12 @@
                 <a:spcPct val="100000"/>
               </a:lnSpc>
               <a:buNone/>
-            </a:pPr>
-            <a:r>
-              <a:rPr b="0" lang="en-US" sz="2000" spc="-1" strike="noStrike">
+              <a:tabLst>
+                <a:tab algn="l" pos="0"/>
+              </a:tabLst>
+            </a:pPr>
+            <a:r>
+              <a:rPr b="0" lang="es-ES" sz="2000" spc="-1" strike="noStrike">
                 <a:solidFill>
                   <a:srgbClr val="000000"/>
                 </a:solidFill>
@@ -478,7 +482,7 @@
         <p:spPr>
           <a:xfrm>
             <a:off x="3884760" y="8685360"/>
-            <a:ext cx="2971440" cy="458280"/>
+            <a:ext cx="2970360" cy="457200"/>
           </a:xfrm>
           <a:prstGeom prst="rect">
             <a:avLst/>
@@ -498,7 +502,10 @@
                 <a:spcPct val="100000"/>
               </a:lnSpc>
               <a:buNone/>
-              <a:defRPr b="0" lang="en-US" sz="1200" spc="-1" strike="noStrike">
+              <a:tabLst>
+                <a:tab algn="l" pos="0"/>
+              </a:tabLst>
+              <a:defRPr b="0" lang="es-ES" sz="1200" spc="-1" strike="noStrike">
                 <a:solidFill>
                   <a:schemeClr val="dk1"/>
                 </a:solidFill>
@@ -513,16 +520,19 @@
                 <a:spcPct val="100000"/>
               </a:lnSpc>
               <a:buNone/>
-            </a:pPr>
-            <a:fld id="{6CA82F06-D612-49D3-B5F9-A3CB3F3917A1}" type="slidenum">
-              <a:rPr b="0" lang="en-US" sz="1200" spc="-1" strike="noStrike">
+              <a:tabLst>
+                <a:tab algn="l" pos="0"/>
+              </a:tabLst>
+            </a:pPr>
+            <a:fld id="{423634A9-3543-4AB3-B4A3-E103FAAE6ED2}" type="slidenum">
+              <a:rPr b="0" lang="es-ES" sz="1200" spc="-1" strike="noStrike">
                 <a:solidFill>
                   <a:schemeClr val="dk1"/>
                 </a:solidFill>
                 <a:latin typeface="+mn-lt"/>
                 <a:ea typeface="+mn-ea"/>
               </a:rPr>
-              <a:t>&lt;número&gt;</a:t>
+              <a:t>11</a:t>
             </a:fld>
             <a:endParaRPr b="0" lang="es-ES" sz="1200" spc="-1" strike="noStrike">
               <a:solidFill>
@@ -568,7 +578,7 @@
         <p:spPr>
           <a:xfrm>
             <a:off x="685800" y="1143000"/>
-            <a:ext cx="5486040" cy="3085920"/>
+            <a:ext cx="5484960" cy="3084840"/>
           </a:xfrm>
           <a:prstGeom prst="rect">
             <a:avLst/>
@@ -591,7 +601,7 @@
         <p:spPr>
           <a:xfrm>
             <a:off x="685800" y="4400640"/>
-            <a:ext cx="5486040" cy="3600000"/>
+            <a:ext cx="5484960" cy="3598920"/>
           </a:xfrm>
           <a:prstGeom prst="rect">
             <a:avLst/>
@@ -611,9 +621,12 @@
                 <a:spcPct val="100000"/>
               </a:lnSpc>
               <a:buNone/>
-            </a:pPr>
-            <a:r>
-              <a:rPr b="0" lang="en-US" sz="2000" spc="-1" strike="noStrike">
+              <a:tabLst>
+                <a:tab algn="l" pos="0"/>
+              </a:tabLst>
+            </a:pPr>
+            <a:r>
+              <a:rPr b="0" lang="es-ES" sz="2000" spc="-1" strike="noStrike">
                 <a:solidFill>
                   <a:srgbClr val="000000"/>
                 </a:solidFill>
@@ -643,7 +656,7 @@
         <p:spPr>
           <a:xfrm>
             <a:off x="3884760" y="8685360"/>
-            <a:ext cx="2971440" cy="458280"/>
+            <a:ext cx="2970360" cy="457200"/>
           </a:xfrm>
           <a:prstGeom prst="rect">
             <a:avLst/>
@@ -663,7 +676,10 @@
                 <a:spcPct val="100000"/>
               </a:lnSpc>
               <a:buNone/>
-              <a:defRPr b="0" lang="en-US" sz="1200" spc="-1" strike="noStrike">
+              <a:tabLst>
+                <a:tab algn="l" pos="0"/>
+              </a:tabLst>
+              <a:defRPr b="0" lang="es-ES" sz="1200" spc="-1" strike="noStrike">
                 <a:solidFill>
                   <a:schemeClr val="dk1"/>
                 </a:solidFill>
@@ -678,9 +694,12 @@
                 <a:spcPct val="100000"/>
               </a:lnSpc>
               <a:buNone/>
-            </a:pPr>
-            <a:fld id="{81206D96-B6E9-46FD-9B79-2E6C86506975}" type="slidenum">
-              <a:rPr b="0" lang="en-US" sz="1200" spc="-1" strike="noStrike">
+              <a:tabLst>
+                <a:tab algn="l" pos="0"/>
+              </a:tabLst>
+            </a:pPr>
+            <a:fld id="{4DF73E7A-BAB5-43B1-A0B6-214FAF33177F}" type="slidenum">
+              <a:rPr b="0" lang="es-ES" sz="1200" spc="-1" strike="noStrike">
                 <a:solidFill>
                   <a:schemeClr val="dk1"/>
                 </a:solidFill>
@@ -733,7 +752,7 @@
         <p:spPr>
           <a:xfrm>
             <a:off x="685800" y="1143000"/>
-            <a:ext cx="5486040" cy="3085920"/>
+            <a:ext cx="5484960" cy="3084840"/>
           </a:xfrm>
           <a:prstGeom prst="rect">
             <a:avLst/>
@@ -756,7 +775,7 @@
         <p:spPr>
           <a:xfrm>
             <a:off x="685800" y="4400640"/>
-            <a:ext cx="5486040" cy="3600000"/>
+            <a:ext cx="5484960" cy="3598920"/>
           </a:xfrm>
           <a:prstGeom prst="rect">
             <a:avLst/>
@@ -776,9 +795,12 @@
                 <a:spcPct val="100000"/>
               </a:lnSpc>
               <a:buNone/>
-            </a:pPr>
-            <a:r>
-              <a:rPr b="0" lang="en-US" sz="2000" spc="-1" strike="noStrike">
+              <a:tabLst>
+                <a:tab algn="l" pos="0"/>
+              </a:tabLst>
+            </a:pPr>
+            <a:r>
+              <a:rPr b="0" lang="es-ES" sz="2000" spc="-1" strike="noStrike">
                 <a:solidFill>
                   <a:srgbClr val="000000"/>
                 </a:solidFill>
@@ -808,7 +830,7 @@
         <p:spPr>
           <a:xfrm>
             <a:off x="3884760" y="8685360"/>
-            <a:ext cx="2971440" cy="458280"/>
+            <a:ext cx="2970360" cy="457200"/>
           </a:xfrm>
           <a:prstGeom prst="rect">
             <a:avLst/>
@@ -828,7 +850,10 @@
                 <a:spcPct val="100000"/>
               </a:lnSpc>
               <a:buNone/>
-              <a:defRPr b="0" lang="en-US" sz="1200" spc="-1" strike="noStrike">
+              <a:tabLst>
+                <a:tab algn="l" pos="0"/>
+              </a:tabLst>
+              <a:defRPr b="0" lang="es-ES" sz="1200" spc="-1" strike="noStrike">
                 <a:solidFill>
                   <a:schemeClr val="dk1"/>
                 </a:solidFill>
@@ -843,9 +868,12 @@
                 <a:spcPct val="100000"/>
               </a:lnSpc>
               <a:buNone/>
-            </a:pPr>
-            <a:fld id="{B4045B09-372B-4D6D-A90A-5DEC7BBB299D}" type="slidenum">
-              <a:rPr b="0" lang="en-US" sz="1200" spc="-1" strike="noStrike">
+              <a:tabLst>
+                <a:tab algn="l" pos="0"/>
+              </a:tabLst>
+            </a:pPr>
+            <a:fld id="{CA147361-98B4-4D61-BE0F-39B37766B7A3}" type="slidenum">
+              <a:rPr b="0" lang="es-ES" sz="1200" spc="-1" strike="noStrike">
                 <a:solidFill>
                   <a:schemeClr val="dk1"/>
                 </a:solidFill>
@@ -898,7 +926,7 @@
         <p:spPr>
           <a:xfrm>
             <a:off x="685800" y="1143000"/>
-            <a:ext cx="5486040" cy="3085920"/>
+            <a:ext cx="5484960" cy="3084840"/>
           </a:xfrm>
           <a:prstGeom prst="rect">
             <a:avLst/>
@@ -921,7 +949,7 @@
         <p:spPr>
           <a:xfrm>
             <a:off x="685800" y="4400640"/>
-            <a:ext cx="5486040" cy="3600000"/>
+            <a:ext cx="5484960" cy="3598920"/>
           </a:xfrm>
           <a:prstGeom prst="rect">
             <a:avLst/>
@@ -941,9 +969,12 @@
                 <a:spcPct val="100000"/>
               </a:lnSpc>
               <a:buNone/>
-            </a:pPr>
-            <a:r>
-              <a:rPr b="0" lang="en-US" sz="2000" spc="-1" strike="noStrike">
+              <a:tabLst>
+                <a:tab algn="l" pos="0"/>
+              </a:tabLst>
+            </a:pPr>
+            <a:r>
+              <a:rPr b="0" lang="es-ES" sz="2000" spc="-1" strike="noStrike">
                 <a:solidFill>
                   <a:srgbClr val="000000"/>
                 </a:solidFill>
@@ -973,7 +1004,7 @@
         <p:spPr>
           <a:xfrm>
             <a:off x="3884760" y="8685360"/>
-            <a:ext cx="2971440" cy="458280"/>
+            <a:ext cx="2970360" cy="457200"/>
           </a:xfrm>
           <a:prstGeom prst="rect">
             <a:avLst/>
@@ -993,7 +1024,10 @@
                 <a:spcPct val="100000"/>
               </a:lnSpc>
               <a:buNone/>
-              <a:defRPr b="0" lang="en-US" sz="1200" spc="-1" strike="noStrike">
+              <a:tabLst>
+                <a:tab algn="l" pos="0"/>
+              </a:tabLst>
+              <a:defRPr b="0" lang="es-ES" sz="1200" spc="-1" strike="noStrike">
                 <a:solidFill>
                   <a:schemeClr val="dk1"/>
                 </a:solidFill>
@@ -1008,16 +1042,19 @@
                 <a:spcPct val="100000"/>
               </a:lnSpc>
               <a:buNone/>
-            </a:pPr>
-            <a:fld id="{12D0FED7-EF07-4118-B1C4-3E01A6EA129C}" type="slidenum">
-              <a:rPr b="0" lang="en-US" sz="1200" spc="-1" strike="noStrike">
+              <a:tabLst>
+                <a:tab algn="l" pos="0"/>
+              </a:tabLst>
+            </a:pPr>
+            <a:fld id="{9FA00944-39EA-447C-BCD5-EBA45CB0C7F0}" type="slidenum">
+              <a:rPr b="0" lang="es-ES" sz="1200" spc="-1" strike="noStrike">
                 <a:solidFill>
                   <a:schemeClr val="dk1"/>
                 </a:solidFill>
                 <a:latin typeface="+mn-lt"/>
                 <a:ea typeface="+mn-ea"/>
               </a:rPr>
-              <a:t>&lt;número&gt;</a:t>
+              <a:t>11</a:t>
             </a:fld>
             <a:endParaRPr b="0" lang="es-ES" sz="1200" spc="-1" strike="noStrike">
               <a:solidFill>
@@ -1063,7 +1100,7 @@
         <p:spPr>
           <a:xfrm>
             <a:off x="685800" y="1143000"/>
-            <a:ext cx="5486040" cy="3085920"/>
+            <a:ext cx="5484960" cy="3084840"/>
           </a:xfrm>
           <a:prstGeom prst="rect">
             <a:avLst/>
@@ -1086,7 +1123,7 @@
         <p:spPr>
           <a:xfrm>
             <a:off x="685800" y="4400640"/>
-            <a:ext cx="5486040" cy="3600000"/>
+            <a:ext cx="5484960" cy="3598920"/>
           </a:xfrm>
           <a:prstGeom prst="rect">
             <a:avLst/>
@@ -1106,9 +1143,12 @@
                 <a:spcPct val="100000"/>
               </a:lnSpc>
               <a:buNone/>
-            </a:pPr>
-            <a:r>
-              <a:rPr b="0" lang="en-US" sz="2000" spc="-1" strike="noStrike">
+              <a:tabLst>
+                <a:tab algn="l" pos="0"/>
+              </a:tabLst>
+            </a:pPr>
+            <a:r>
+              <a:rPr b="0" lang="es-ES" sz="2000" spc="-1" strike="noStrike">
                 <a:solidFill>
                   <a:srgbClr val="000000"/>
                 </a:solidFill>
@@ -1138,7 +1178,7 @@
         <p:spPr>
           <a:xfrm>
             <a:off x="3884760" y="8685360"/>
-            <a:ext cx="2971440" cy="458280"/>
+            <a:ext cx="2970360" cy="457200"/>
           </a:xfrm>
           <a:prstGeom prst="rect">
             <a:avLst/>
@@ -1158,7 +1198,10 @@
                 <a:spcPct val="100000"/>
               </a:lnSpc>
               <a:buNone/>
-              <a:defRPr b="0" lang="en-US" sz="1200" spc="-1" strike="noStrike">
+              <a:tabLst>
+                <a:tab algn="l" pos="0"/>
+              </a:tabLst>
+              <a:defRPr b="0" lang="es-ES" sz="1200" spc="-1" strike="noStrike">
                 <a:solidFill>
                   <a:schemeClr val="dk1"/>
                 </a:solidFill>
@@ -1173,16 +1216,19 @@
                 <a:spcPct val="100000"/>
               </a:lnSpc>
               <a:buNone/>
-            </a:pPr>
-            <a:fld id="{5A3A8A6D-81F5-4C95-8ADE-720FC654ECD5}" type="slidenum">
-              <a:rPr b="0" lang="en-US" sz="1200" spc="-1" strike="noStrike">
+              <a:tabLst>
+                <a:tab algn="l" pos="0"/>
+              </a:tabLst>
+            </a:pPr>
+            <a:fld id="{2FD9972F-CB47-42A6-93AD-5F929BA9C612}" type="slidenum">
+              <a:rPr b="0" lang="es-ES" sz="1200" spc="-1" strike="noStrike">
                 <a:solidFill>
                   <a:schemeClr val="dk1"/>
                 </a:solidFill>
                 <a:latin typeface="+mn-lt"/>
                 <a:ea typeface="+mn-ea"/>
               </a:rPr>
-              <a:t>&lt;número&gt;</a:t>
+              <a:t>11</a:t>
             </a:fld>
             <a:endParaRPr b="0" lang="es-ES" sz="1200" spc="-1" strike="noStrike">
               <a:solidFill>
@@ -1228,7 +1274,7 @@
         <p:spPr>
           <a:xfrm>
             <a:off x="685800" y="1143000"/>
-            <a:ext cx="5486040" cy="3085920"/>
+            <a:ext cx="5484960" cy="3084840"/>
           </a:xfrm>
           <a:prstGeom prst="rect">
             <a:avLst/>
@@ -1251,7 +1297,7 @@
         <p:spPr>
           <a:xfrm>
             <a:off x="685800" y="4400640"/>
-            <a:ext cx="5486040" cy="3600000"/>
+            <a:ext cx="5484960" cy="3598920"/>
           </a:xfrm>
           <a:prstGeom prst="rect">
             <a:avLst/>
@@ -1271,9 +1317,12 @@
                 <a:spcPct val="100000"/>
               </a:lnSpc>
               <a:buNone/>
-            </a:pPr>
-            <a:r>
-              <a:rPr b="0" lang="en-US" sz="2000" spc="-1" strike="noStrike">
+              <a:tabLst>
+                <a:tab algn="l" pos="0"/>
+              </a:tabLst>
+            </a:pPr>
+            <a:r>
+              <a:rPr b="0" lang="es-ES" sz="2000" spc="-1" strike="noStrike">
                 <a:solidFill>
                   <a:srgbClr val="000000"/>
                 </a:solidFill>
@@ -1303,7 +1352,7 @@
         <p:spPr>
           <a:xfrm>
             <a:off x="3884760" y="8685360"/>
-            <a:ext cx="2971440" cy="458280"/>
+            <a:ext cx="2970360" cy="457200"/>
           </a:xfrm>
           <a:prstGeom prst="rect">
             <a:avLst/>
@@ -1323,7 +1372,10 @@
                 <a:spcPct val="100000"/>
               </a:lnSpc>
               <a:buNone/>
-              <a:defRPr b="0" lang="en-US" sz="1200" spc="-1" strike="noStrike">
+              <a:tabLst>
+                <a:tab algn="l" pos="0"/>
+              </a:tabLst>
+              <a:defRPr b="0" lang="es-ES" sz="1200" spc="-1" strike="noStrike">
                 <a:solidFill>
                   <a:schemeClr val="dk1"/>
                 </a:solidFill>
@@ -1338,16 +1390,19 @@
                 <a:spcPct val="100000"/>
               </a:lnSpc>
               <a:buNone/>
-            </a:pPr>
-            <a:fld id="{BBD8DA82-F674-42BC-9676-F5469BCFA310}" type="slidenum">
-              <a:rPr b="0" lang="en-US" sz="1200" spc="-1" strike="noStrike">
+              <a:tabLst>
+                <a:tab algn="l" pos="0"/>
+              </a:tabLst>
+            </a:pPr>
+            <a:fld id="{E52E67A8-F994-48FB-A826-B013CD50EDC3}" type="slidenum">
+              <a:rPr b="0" lang="es-ES" sz="1200" spc="-1" strike="noStrike">
                 <a:solidFill>
                   <a:schemeClr val="dk1"/>
                 </a:solidFill>
                 <a:latin typeface="+mn-lt"/>
                 <a:ea typeface="+mn-ea"/>
               </a:rPr>
-              <a:t>&lt;número&gt;</a:t>
+              <a:t>11</a:t>
             </a:fld>
             <a:endParaRPr b="0" lang="es-ES" sz="1200" spc="-1" strike="noStrike">
               <a:solidFill>
@@ -1393,7 +1448,7 @@
         <p:spPr>
           <a:xfrm>
             <a:off x="685800" y="1143000"/>
-            <a:ext cx="5486040" cy="3085920"/>
+            <a:ext cx="5484960" cy="3084840"/>
           </a:xfrm>
           <a:prstGeom prst="rect">
             <a:avLst/>
@@ -1416,7 +1471,7 @@
         <p:spPr>
           <a:xfrm>
             <a:off x="685800" y="4400640"/>
-            <a:ext cx="5486040" cy="3600000"/>
+            <a:ext cx="5484960" cy="3598920"/>
           </a:xfrm>
           <a:prstGeom prst="rect">
             <a:avLst/>
@@ -1436,9 +1491,12 @@
                 <a:spcPct val="100000"/>
               </a:lnSpc>
               <a:buNone/>
-            </a:pPr>
-            <a:r>
-              <a:rPr b="0" lang="en-US" sz="2000" spc="-1" strike="noStrike">
+              <a:tabLst>
+                <a:tab algn="l" pos="0"/>
+              </a:tabLst>
+            </a:pPr>
+            <a:r>
+              <a:rPr b="0" lang="es-ES" sz="2000" spc="-1" strike="noStrike">
                 <a:solidFill>
                   <a:srgbClr val="000000"/>
                 </a:solidFill>
@@ -1468,7 +1526,7 @@
         <p:spPr>
           <a:xfrm>
             <a:off x="3884760" y="8685360"/>
-            <a:ext cx="2971440" cy="458280"/>
+            <a:ext cx="2970360" cy="457200"/>
           </a:xfrm>
           <a:prstGeom prst="rect">
             <a:avLst/>
@@ -1488,7 +1546,10 @@
                 <a:spcPct val="100000"/>
               </a:lnSpc>
               <a:buNone/>
-              <a:defRPr b="0" lang="en-US" sz="1200" spc="-1" strike="noStrike">
+              <a:tabLst>
+                <a:tab algn="l" pos="0"/>
+              </a:tabLst>
+              <a:defRPr b="0" lang="es-ES" sz="1200" spc="-1" strike="noStrike">
                 <a:solidFill>
                   <a:schemeClr val="dk1"/>
                 </a:solidFill>
@@ -1503,9 +1564,12 @@
                 <a:spcPct val="100000"/>
               </a:lnSpc>
               <a:buNone/>
-            </a:pPr>
-            <a:fld id="{CADB49F3-2379-4CE5-8AEB-24A6A0721876}" type="slidenum">
-              <a:rPr b="0" lang="en-US" sz="1200" spc="-1" strike="noStrike">
+              <a:tabLst>
+                <a:tab algn="l" pos="0"/>
+              </a:tabLst>
+            </a:pPr>
+            <a:fld id="{19F27EA6-50FD-4893-8486-7440309E7E08}" type="slidenum">
+              <a:rPr b="0" lang="es-ES" sz="1200" spc="-1" strike="noStrike">
                 <a:solidFill>
                   <a:schemeClr val="dk1"/>
                 </a:solidFill>
@@ -1558,7 +1622,7 @@
         <p:spPr>
           <a:xfrm>
             <a:off x="685800" y="1143000"/>
-            <a:ext cx="5486040" cy="3085920"/>
+            <a:ext cx="5484960" cy="3084840"/>
           </a:xfrm>
           <a:prstGeom prst="rect">
             <a:avLst/>
@@ -1581,7 +1645,7 @@
         <p:spPr>
           <a:xfrm>
             <a:off x="685800" y="4400640"/>
-            <a:ext cx="5486040" cy="3600000"/>
+            <a:ext cx="5484960" cy="3598920"/>
           </a:xfrm>
           <a:prstGeom prst="rect">
             <a:avLst/>
@@ -1601,9 +1665,12 @@
                 <a:spcPct val="100000"/>
               </a:lnSpc>
               <a:buNone/>
-            </a:pPr>
-            <a:r>
-              <a:rPr b="0" lang="en-US" sz="2000" spc="-1" strike="noStrike">
+              <a:tabLst>
+                <a:tab algn="l" pos="0"/>
+              </a:tabLst>
+            </a:pPr>
+            <a:r>
+              <a:rPr b="0" lang="es-ES" sz="2000" spc="-1" strike="noStrike">
                 <a:solidFill>
                   <a:srgbClr val="000000"/>
                 </a:solidFill>
@@ -1633,7 +1700,7 @@
         <p:spPr>
           <a:xfrm>
             <a:off x="3884760" y="8685360"/>
-            <a:ext cx="2971440" cy="458280"/>
+            <a:ext cx="2970360" cy="457200"/>
           </a:xfrm>
           <a:prstGeom prst="rect">
             <a:avLst/>
@@ -1653,7 +1720,10 @@
                 <a:spcPct val="100000"/>
               </a:lnSpc>
               <a:buNone/>
-              <a:defRPr b="0" lang="en-US" sz="1200" spc="-1" strike="noStrike">
+              <a:tabLst>
+                <a:tab algn="l" pos="0"/>
+              </a:tabLst>
+              <a:defRPr b="0" lang="es-ES" sz="1200" spc="-1" strike="noStrike">
                 <a:solidFill>
                   <a:schemeClr val="dk1"/>
                 </a:solidFill>
@@ -1668,9 +1738,12 @@
                 <a:spcPct val="100000"/>
               </a:lnSpc>
               <a:buNone/>
-            </a:pPr>
-            <a:fld id="{08A6CE0A-0937-461A-8C48-FBA2D81ADB7F}" type="slidenum">
-              <a:rPr b="0" lang="en-US" sz="1200" spc="-1" strike="noStrike">
+              <a:tabLst>
+                <a:tab algn="l" pos="0"/>
+              </a:tabLst>
+            </a:pPr>
+            <a:fld id="{FE49541D-6762-4E66-9C4D-BE0D7FE42A1A}" type="slidenum">
+              <a:rPr b="0" lang="es-ES" sz="1200" spc="-1" strike="noStrike">
                 <a:solidFill>
                   <a:schemeClr val="dk1"/>
                 </a:solidFill>
@@ -1723,7 +1796,7 @@
         <p:spPr>
           <a:xfrm>
             <a:off x="685800" y="1143000"/>
-            <a:ext cx="5486040" cy="3085920"/>
+            <a:ext cx="5484960" cy="3084840"/>
           </a:xfrm>
           <a:prstGeom prst="rect">
             <a:avLst/>
@@ -1746,7 +1819,7 @@
         <p:spPr>
           <a:xfrm>
             <a:off x="685800" y="4400640"/>
-            <a:ext cx="5486040" cy="3600000"/>
+            <a:ext cx="5484960" cy="3598920"/>
           </a:xfrm>
           <a:prstGeom prst="rect">
             <a:avLst/>
@@ -1766,9 +1839,12 @@
                 <a:spcPct val="100000"/>
               </a:lnSpc>
               <a:buNone/>
-            </a:pPr>
-            <a:r>
-              <a:rPr b="0" lang="en-US" sz="2000" spc="-1" strike="noStrike">
+              <a:tabLst>
+                <a:tab algn="l" pos="0"/>
+              </a:tabLst>
+            </a:pPr>
+            <a:r>
+              <a:rPr b="0" lang="es-ES" sz="2000" spc="-1" strike="noStrike">
                 <a:solidFill>
                   <a:srgbClr val="000000"/>
                 </a:solidFill>
@@ -1798,7 +1874,7 @@
         <p:spPr>
           <a:xfrm>
             <a:off x="3884760" y="8685360"/>
-            <a:ext cx="2971440" cy="458280"/>
+            <a:ext cx="2970360" cy="457200"/>
           </a:xfrm>
           <a:prstGeom prst="rect">
             <a:avLst/>
@@ -1818,7 +1894,10 @@
                 <a:spcPct val="100000"/>
               </a:lnSpc>
               <a:buNone/>
-              <a:defRPr b="0" lang="en-US" sz="1200" spc="-1" strike="noStrike">
+              <a:tabLst>
+                <a:tab algn="l" pos="0"/>
+              </a:tabLst>
+              <a:defRPr b="0" lang="es-ES" sz="1200" spc="-1" strike="noStrike">
                 <a:solidFill>
                   <a:schemeClr val="dk1"/>
                 </a:solidFill>
@@ -1833,9 +1912,12 @@
                 <a:spcPct val="100000"/>
               </a:lnSpc>
               <a:buNone/>
-            </a:pPr>
-            <a:fld id="{1D391298-5551-4F66-8567-79C4300C3E36}" type="slidenum">
-              <a:rPr b="0" lang="en-US" sz="1200" spc="-1" strike="noStrike">
+              <a:tabLst>
+                <a:tab algn="l" pos="0"/>
+              </a:tabLst>
+            </a:pPr>
+            <a:fld id="{14594A93-1429-4B5B-9B83-3DF4C65318B8}" type="slidenum">
+              <a:rPr b="0" lang="es-ES" sz="1200" spc="-1" strike="noStrike">
                 <a:solidFill>
                   <a:schemeClr val="dk1"/>
                 </a:solidFill>
@@ -1888,7 +1970,7 @@
         <p:spPr>
           <a:xfrm>
             <a:off x="685800" y="1143000"/>
-            <a:ext cx="5486040" cy="3085920"/>
+            <a:ext cx="5484960" cy="3084840"/>
           </a:xfrm>
           <a:prstGeom prst="rect">
             <a:avLst/>
@@ -1911,7 +1993,7 @@
         <p:spPr>
           <a:xfrm>
             <a:off x="685800" y="4400640"/>
-            <a:ext cx="5486040" cy="3600000"/>
+            <a:ext cx="5484960" cy="3598920"/>
           </a:xfrm>
           <a:prstGeom prst="rect">
             <a:avLst/>
@@ -1931,9 +2013,12 @@
                 <a:spcPct val="100000"/>
               </a:lnSpc>
               <a:buNone/>
-            </a:pPr>
-            <a:r>
-              <a:rPr b="0" lang="en-US" sz="2000" spc="-1" strike="noStrike">
+              <a:tabLst>
+                <a:tab algn="l" pos="0"/>
+              </a:tabLst>
+            </a:pPr>
+            <a:r>
+              <a:rPr b="0" lang="es-ES" sz="2000" spc="-1" strike="noStrike">
                 <a:solidFill>
                   <a:srgbClr val="000000"/>
                 </a:solidFill>
@@ -1963,7 +2048,7 @@
         <p:spPr>
           <a:xfrm>
             <a:off x="3884760" y="8685360"/>
-            <a:ext cx="2971440" cy="458280"/>
+            <a:ext cx="2970360" cy="457200"/>
           </a:xfrm>
           <a:prstGeom prst="rect">
             <a:avLst/>
@@ -1983,7 +2068,10 @@
                 <a:spcPct val="100000"/>
               </a:lnSpc>
               <a:buNone/>
-              <a:defRPr b="0" lang="en-US" sz="1200" spc="-1" strike="noStrike">
+              <a:tabLst>
+                <a:tab algn="l" pos="0"/>
+              </a:tabLst>
+              <a:defRPr b="0" lang="es-ES" sz="1200" spc="-1" strike="noStrike">
                 <a:solidFill>
                   <a:schemeClr val="dk1"/>
                 </a:solidFill>
@@ -1998,9 +2086,12 @@
                 <a:spcPct val="100000"/>
               </a:lnSpc>
               <a:buNone/>
-            </a:pPr>
-            <a:fld id="{7A2765E8-A494-440F-94C2-4942090AA6E8}" type="slidenum">
-              <a:rPr b="0" lang="en-US" sz="1200" spc="-1" strike="noStrike">
+              <a:tabLst>
+                <a:tab algn="l" pos="0"/>
+              </a:tabLst>
+            </a:pPr>
+            <a:fld id="{9012FF33-4BE4-4A5B-A0C8-C680B5168B07}" type="slidenum">
+              <a:rPr b="0" lang="es-ES" sz="1200" spc="-1" strike="noStrike">
                 <a:solidFill>
                   <a:schemeClr val="dk1"/>
                 </a:solidFill>
@@ -2053,7 +2144,7 @@
         <p:spPr>
           <a:xfrm>
             <a:off x="685800" y="1143000"/>
-            <a:ext cx="5486040" cy="3085920"/>
+            <a:ext cx="5484960" cy="3084840"/>
           </a:xfrm>
           <a:prstGeom prst="rect">
             <a:avLst/>
@@ -2076,7 +2167,7 @@
         <p:spPr>
           <a:xfrm>
             <a:off x="685800" y="4400640"/>
-            <a:ext cx="5486040" cy="3600000"/>
+            <a:ext cx="5484960" cy="3598920"/>
           </a:xfrm>
           <a:prstGeom prst="rect">
             <a:avLst/>
@@ -2096,9 +2187,12 @@
                 <a:spcPct val="100000"/>
               </a:lnSpc>
               <a:buNone/>
-            </a:pPr>
-            <a:r>
-              <a:rPr b="0" lang="en-US" sz="2000" spc="-1" strike="noStrike">
+              <a:tabLst>
+                <a:tab algn="l" pos="0"/>
+              </a:tabLst>
+            </a:pPr>
+            <a:r>
+              <a:rPr b="0" lang="es-ES" sz="2000" spc="-1" strike="noStrike">
                 <a:solidFill>
                   <a:srgbClr val="000000"/>
                 </a:solidFill>
@@ -2128,7 +2222,7 @@
         <p:spPr>
           <a:xfrm>
             <a:off x="3884760" y="8685360"/>
-            <a:ext cx="2971440" cy="458280"/>
+            <a:ext cx="2970360" cy="457200"/>
           </a:xfrm>
           <a:prstGeom prst="rect">
             <a:avLst/>
@@ -2148,7 +2242,10 @@
                 <a:spcPct val="100000"/>
               </a:lnSpc>
               <a:buNone/>
-              <a:defRPr b="0" lang="en-US" sz="1200" spc="-1" strike="noStrike">
+              <a:tabLst>
+                <a:tab algn="l" pos="0"/>
+              </a:tabLst>
+              <a:defRPr b="0" lang="es-ES" sz="1200" spc="-1" strike="noStrike">
                 <a:solidFill>
                   <a:schemeClr val="dk1"/>
                 </a:solidFill>
@@ -2163,9 +2260,12 @@
                 <a:spcPct val="100000"/>
               </a:lnSpc>
               <a:buNone/>
-            </a:pPr>
-            <a:fld id="{6482D32B-4814-487E-BD44-73D279FA0753}" type="slidenum">
-              <a:rPr b="0" lang="en-US" sz="1200" spc="-1" strike="noStrike">
+              <a:tabLst>
+                <a:tab algn="l" pos="0"/>
+              </a:tabLst>
+            </a:pPr>
+            <a:fld id="{517D656C-0E47-4897-92D0-F32F3D2B454C}" type="slidenum">
+              <a:rPr b="0" lang="es-ES" sz="1200" spc="-1" strike="noStrike">
                 <a:solidFill>
                   <a:schemeClr val="dk1"/>
                 </a:solidFill>
@@ -2301,37 +2401,73 @@
         </p:nvSpPr>
         <p:spPr>
           <a:xfrm>
-            <a:off x="812880" y="1051560"/>
-            <a:ext cx="10566000" cy="600120"/>
-          </a:xfrm>
-          <a:prstGeom prst="rect">
-            <a:avLst/>
-          </a:prstGeom>
-          <a:noFill/>
-          <a:ln w="0">
-            <a:noFill/>
-          </a:ln>
-        </p:spPr>
-        <p:txBody>
-          <a:bodyPr lIns="0" rIns="0" tIns="0" bIns="0" anchor="t">
+            <a:off x="609480" y="273600"/>
+            <a:ext cx="10972440" cy="1144800"/>
+          </a:xfrm>
+          <a:prstGeom prst="rect">
+            <a:avLst/>
+          </a:prstGeom>
+          <a:noFill/>
+          <a:ln w="0">
+            <a:noFill/>
+          </a:ln>
+        </p:spPr>
+        <p:txBody>
+          <a:bodyPr lIns="0" rIns="0" tIns="0" bIns="0" anchor="ctr">
             <a:noAutofit/>
           </a:bodyPr>
           <a:p>
-            <a:pPr indent="0">
+            <a:pPr indent="0" algn="ctr">
               <a:buNone/>
             </a:pPr>
             <a:r>
-              <a:rPr b="0" lang="es-ES" sz="3000" spc="-1" strike="noStrike">
-                <a:solidFill>
-                  <a:schemeClr val="dk1"/>
+              <a:rPr b="0" lang="es-ES" sz="4400" spc="-1" strike="noStrike">
+                <a:solidFill>
+                  <a:srgbClr val="000000"/>
                 </a:solidFill>
                 <a:latin typeface="Arial"/>
               </a:rPr>
-              <a:t>Pulse para editar el formato del texto de título</a:t>
-            </a:r>
-            <a:endParaRPr b="0" lang="es-ES" sz="3000" spc="-1" strike="noStrike">
-              <a:solidFill>
-                <a:schemeClr val="dk1"/>
+              <a:t>Pulse para </a:t>
+            </a:r>
+            <a:r>
+              <a:rPr b="0" lang="es-ES" sz="4400" spc="-1" strike="noStrike">
+                <a:solidFill>
+                  <a:srgbClr val="000000"/>
+                </a:solidFill>
+                <a:latin typeface="Arial"/>
+              </a:rPr>
+              <a:t>editar el </a:t>
+            </a:r>
+            <a:r>
+              <a:rPr b="0" lang="es-ES" sz="4400" spc="-1" strike="noStrike">
+                <a:solidFill>
+                  <a:srgbClr val="000000"/>
+                </a:solidFill>
+                <a:latin typeface="Arial"/>
+              </a:rPr>
+              <a:t>formato del </a:t>
+            </a:r>
+            <a:r>
+              <a:rPr b="0" lang="es-ES" sz="4400" spc="-1" strike="noStrike">
+                <a:solidFill>
+                  <a:srgbClr val="000000"/>
+                </a:solidFill>
+                <a:latin typeface="Arial"/>
+              </a:rPr>
+              <a:t>texto de </a:t>
+            </a:r>
+            <a:r>
+              <a:rPr b="0" lang="es-ES" sz="4400" spc="-1" strike="noStrike">
+                <a:solidFill>
+                  <a:srgbClr val="000000"/>
+                </a:solidFill>
+                <a:latin typeface="Arial"/>
+              </a:rPr>
+              <a:t>título</a:t>
+            </a:r>
+            <a:endParaRPr b="0" lang="es-ES" sz="4400" spc="-1" strike="noStrike">
+              <a:solidFill>
+                <a:srgbClr val="000000"/>
               </a:solidFill>
               <a:latin typeface="Arial"/>
             </a:endParaRPr>
@@ -2350,8 +2486,8 @@
         </p:nvSpPr>
         <p:spPr>
           <a:xfrm>
-            <a:off x="812880" y="1956960"/>
-            <a:ext cx="10566000" cy="4087800"/>
+            <a:off x="609480" y="1604520"/>
+            <a:ext cx="10972440" cy="3977280"/>
           </a:xfrm>
           <a:prstGeom prst="rect">
             <a:avLst/>
@@ -2363,7 +2499,7 @@
         </p:spPr>
         <p:txBody>
           <a:bodyPr lIns="0" rIns="0" tIns="0" bIns="0" anchor="t">
-            <a:noAutofit/>
+            <a:normAutofit/>
           </a:bodyPr>
           <a:p>
             <a:pPr marL="432000" indent="-324000">
@@ -2378,17 +2514,17 @@
               <a:buChar char=""/>
             </a:pPr>
             <a:r>
-              <a:rPr b="0" lang="es-ES" sz="1600" spc="-1" strike="noStrike">
-                <a:solidFill>
-                  <a:schemeClr val="dk1"/>
+              <a:rPr b="0" lang="es-ES" sz="3200" spc="-1" strike="noStrike">
+                <a:solidFill>
+                  <a:srgbClr val="000000"/>
                 </a:solidFill>
                 <a:latin typeface="Arial"/>
               </a:rPr>
               <a:t>Pulse para editar el formato de texto del esquema</a:t>
             </a:r>
-            <a:endParaRPr b="0" lang="es-ES" sz="1600" spc="-1" strike="noStrike">
-              <a:solidFill>
-                <a:schemeClr val="dk1"/>
+            <a:endParaRPr b="0" lang="es-ES" sz="3200" spc="-1" strike="noStrike">
+              <a:solidFill>
+                <a:srgbClr val="000000"/>
               </a:solidFill>
               <a:latin typeface="Arial"/>
             </a:endParaRPr>
@@ -2406,17 +2542,17 @@
               <a:buChar char=""/>
             </a:pPr>
             <a:r>
-              <a:rPr b="0" lang="es-ES" sz="1600" spc="-1" strike="noStrike">
-                <a:solidFill>
-                  <a:schemeClr val="dk1"/>
+              <a:rPr b="0" lang="es-ES" sz="2800" spc="-1" strike="noStrike">
+                <a:solidFill>
+                  <a:srgbClr val="000000"/>
                 </a:solidFill>
                 <a:latin typeface="Arial"/>
               </a:rPr>
               <a:t>Segundo nivel del esquema</a:t>
             </a:r>
-            <a:endParaRPr b="0" lang="es-ES" sz="1600" spc="-1" strike="noStrike">
-              <a:solidFill>
-                <a:schemeClr val="dk1"/>
+            <a:endParaRPr b="0" lang="es-ES" sz="2800" spc="-1" strike="noStrike">
+              <a:solidFill>
+                <a:srgbClr val="000000"/>
               </a:solidFill>
               <a:latin typeface="Arial"/>
             </a:endParaRPr>
@@ -2434,17 +2570,17 @@
               <a:buChar char=""/>
             </a:pPr>
             <a:r>
-              <a:rPr b="0" lang="es-ES" sz="1600" spc="-1" strike="noStrike">
-                <a:solidFill>
-                  <a:schemeClr val="dk1"/>
+              <a:rPr b="0" lang="es-ES" sz="2400" spc="-1" strike="noStrike">
+                <a:solidFill>
+                  <a:srgbClr val="000000"/>
                 </a:solidFill>
                 <a:latin typeface="Arial"/>
               </a:rPr>
               <a:t>Tercer nivel del esquema</a:t>
             </a:r>
-            <a:endParaRPr b="0" lang="es-ES" sz="1600" spc="-1" strike="noStrike">
-              <a:solidFill>
-                <a:schemeClr val="dk1"/>
+            <a:endParaRPr b="0" lang="es-ES" sz="2400" spc="-1" strike="noStrike">
+              <a:solidFill>
+                <a:srgbClr val="000000"/>
               </a:solidFill>
               <a:latin typeface="Arial"/>
             </a:endParaRPr>
@@ -2462,17 +2598,17 @@
               <a:buChar char=""/>
             </a:pPr>
             <a:r>
-              <a:rPr b="0" lang="es-ES" sz="1600" spc="-1" strike="noStrike">
-                <a:solidFill>
-                  <a:schemeClr val="dk1"/>
+              <a:rPr b="0" lang="es-ES" sz="2000" spc="-1" strike="noStrike">
+                <a:solidFill>
+                  <a:srgbClr val="000000"/>
                 </a:solidFill>
                 <a:latin typeface="Arial"/>
               </a:rPr>
               <a:t>Cuarto nivel del esquema</a:t>
             </a:r>
-            <a:endParaRPr b="0" lang="es-ES" sz="1600" spc="-1" strike="noStrike">
-              <a:solidFill>
-                <a:schemeClr val="dk1"/>
+            <a:endParaRPr b="0" lang="es-ES" sz="2000" spc="-1" strike="noStrike">
+              <a:solidFill>
+                <a:srgbClr val="000000"/>
               </a:solidFill>
               <a:latin typeface="Arial"/>
             </a:endParaRPr>
@@ -2490,17 +2626,17 @@
               <a:buChar char=""/>
             </a:pPr>
             <a:r>
-              <a:rPr b="0" lang="es-ES" sz="1600" spc="-1" strike="noStrike">
-                <a:solidFill>
-                  <a:schemeClr val="dk1"/>
+              <a:rPr b="0" lang="es-ES" sz="2000" spc="-1" strike="noStrike">
+                <a:solidFill>
+                  <a:srgbClr val="000000"/>
                 </a:solidFill>
                 <a:latin typeface="Arial"/>
               </a:rPr>
               <a:t>Quinto nivel del esquema</a:t>
             </a:r>
-            <a:endParaRPr b="0" lang="es-ES" sz="1600" spc="-1" strike="noStrike">
-              <a:solidFill>
-                <a:schemeClr val="dk1"/>
+            <a:endParaRPr b="0" lang="es-ES" sz="2000" spc="-1" strike="noStrike">
+              <a:solidFill>
+                <a:srgbClr val="000000"/>
               </a:solidFill>
               <a:latin typeface="Arial"/>
             </a:endParaRPr>
@@ -2518,17 +2654,17 @@
               <a:buChar char=""/>
             </a:pPr>
             <a:r>
-              <a:rPr b="0" lang="es-ES" sz="1600" spc="-1" strike="noStrike">
-                <a:solidFill>
-                  <a:schemeClr val="dk1"/>
+              <a:rPr b="0" lang="es-ES" sz="2000" spc="-1" strike="noStrike">
+                <a:solidFill>
+                  <a:srgbClr val="000000"/>
                 </a:solidFill>
                 <a:latin typeface="Arial"/>
               </a:rPr>
               <a:t>Sexto nivel del esquema</a:t>
             </a:r>
-            <a:endParaRPr b="0" lang="es-ES" sz="1600" spc="-1" strike="noStrike">
-              <a:solidFill>
-                <a:schemeClr val="dk1"/>
+            <a:endParaRPr b="0" lang="es-ES" sz="2000" spc="-1" strike="noStrike">
+              <a:solidFill>
+                <a:srgbClr val="000000"/>
               </a:solidFill>
               <a:latin typeface="Arial"/>
             </a:endParaRPr>
@@ -2546,17 +2682,17 @@
               <a:buChar char=""/>
             </a:pPr>
             <a:r>
-              <a:rPr b="0" lang="es-ES" sz="1600" spc="-1" strike="noStrike">
-                <a:solidFill>
-                  <a:schemeClr val="dk1"/>
+              <a:rPr b="0" lang="es-ES" sz="2000" spc="-1" strike="noStrike">
+                <a:solidFill>
+                  <a:srgbClr val="000000"/>
                 </a:solidFill>
                 <a:latin typeface="Arial"/>
               </a:rPr>
               <a:t>Séptimo nivel del esquema</a:t>
             </a:r>
-            <a:endParaRPr b="0" lang="es-ES" sz="1600" spc="-1" strike="noStrike">
-              <a:solidFill>
-                <a:schemeClr val="dk1"/>
+            <a:endParaRPr b="0" lang="es-ES" sz="2000" spc="-1" strike="noStrike">
+              <a:solidFill>
+                <a:srgbClr val="000000"/>
               </a:solidFill>
               <a:latin typeface="Arial"/>
             </a:endParaRPr>
@@ -2609,7 +2745,7 @@
         <p:spPr>
           <a:xfrm>
             <a:off x="812880" y="2068920"/>
-            <a:ext cx="10883160" cy="1198440"/>
+            <a:ext cx="10882080" cy="1197360"/>
           </a:xfrm>
           <a:prstGeom prst="rect">
             <a:avLst/>
@@ -2634,7 +2770,7 @@
               </a:tabLst>
             </a:pPr>
             <a:r>
-              <a:rPr b="1" lang="en-US" sz="4200" spc="-1" strike="noStrike">
+              <a:rPr b="1" lang="es-ES" sz="4200" spc="-1" strike="noStrike">
                 <a:solidFill>
                   <a:srgbClr val="f7f6f2"/>
                 </a:solidFill>
@@ -2645,7 +2781,7 @@
             </a:r>
             <a:endParaRPr b="0" lang="es-ES" sz="4200" spc="-1" strike="noStrike">
               <a:solidFill>
-                <a:schemeClr val="dk1"/>
+                <a:srgbClr val="ffffff"/>
               </a:solidFill>
               <a:latin typeface="Arial"/>
             </a:endParaRPr>
@@ -2661,7 +2797,7 @@
         <p:spPr>
           <a:xfrm>
             <a:off x="812880" y="3496320"/>
-            <a:ext cx="11378880" cy="327240"/>
+            <a:ext cx="11377800" cy="326160"/>
           </a:xfrm>
           <a:prstGeom prst="rect">
             <a:avLst/>
@@ -2691,7 +2827,7 @@
               </a:tabLst>
             </a:pPr>
             <a:r>
-              <a:rPr b="0" lang="en-US" sz="1700" spc="-1" strike="noStrike">
+              <a:rPr b="0" lang="es-ES" sz="1700" spc="-1" strike="noStrike">
                 <a:solidFill>
                   <a:srgbClr val="c9d6e3"/>
                 </a:solidFill>
@@ -2718,7 +2854,7 @@
         <p:spPr>
           <a:xfrm>
             <a:off x="812880" y="4052520"/>
-            <a:ext cx="10883160" cy="558360"/>
+            <a:ext cx="10882080" cy="557280"/>
           </a:xfrm>
           <a:prstGeom prst="rect">
             <a:avLst/>
@@ -2748,7 +2884,7 @@
               </a:tabLst>
             </a:pPr>
             <a:r>
-              <a:rPr b="0" lang="en-US" sz="1500" spc="-1" strike="noStrike">
+              <a:rPr b="0" lang="es-ES" sz="1500" spc="-1" strike="noStrike">
                 <a:solidFill>
                   <a:srgbClr val="f7f6f2"/>
                 </a:solidFill>
@@ -2758,9 +2894,9 @@
               <a:t>Datos reales: Evaluaciones Agropecuarias Municipales (UPRA), 2019–2025 · 166.732 registros, 1.103 municipios · </a:t>
             </a:r>
             <a:r>
-              <a:rPr b="0" lang="en-US" sz="1500" spc="-1" strike="noStrike" u="sng">
-                <a:solidFill>
-                  <a:srgbClr val="9cc3ea"/>
+              <a:rPr b="0" lang="es-ES" sz="1500" spc="-1" strike="noStrike" u="sng">
+                <a:solidFill>
+                  <a:srgbClr val="0563c1"/>
                 </a:solidFill>
                 <a:uFillTx/>
                 <a:latin typeface="Arial"/>
@@ -2787,7 +2923,7 @@
         <p:spPr>
           <a:xfrm>
             <a:off x="812880" y="6238440"/>
-            <a:ext cx="10883160" cy="238320"/>
+            <a:ext cx="10882080" cy="237240"/>
           </a:xfrm>
           <a:prstGeom prst="rect">
             <a:avLst/>
@@ -2817,7 +2953,7 @@
               </a:tabLst>
             </a:pPr>
             <a:r>
-              <a:rPr b="0" lang="en-US" sz="1200" spc="-1" strike="noStrike">
+              <a:rPr b="0" lang="es-ES" sz="1200" spc="-1" strike="noStrike">
                 <a:solidFill>
                   <a:srgbClr val="c9d6e3"/>
                 </a:solidFill>
@@ -2881,7 +3017,7 @@
         <p:spPr>
           <a:xfrm>
             <a:off x="812880" y="812880"/>
-            <a:ext cx="10883160" cy="273960"/>
+            <a:ext cx="10882080" cy="272880"/>
           </a:xfrm>
           <a:prstGeom prst="rect">
             <a:avLst/>
@@ -2911,7 +3047,7 @@
               </a:tabLst>
             </a:pPr>
             <a:r>
-              <a:rPr b="1" lang="en-US" sz="1400" spc="-1" strike="noStrike">
+              <a:rPr b="1" lang="es-ES" sz="1400" spc="-1" strike="noStrike">
                 <a:solidFill>
                   <a:srgbClr val="b4530f"/>
                 </a:solidFill>
@@ -2942,7 +3078,7 @@
         <p:spPr>
           <a:xfrm>
             <a:off x="812880" y="1290240"/>
-            <a:ext cx="10883160" cy="500040"/>
+            <a:ext cx="10882080" cy="498960"/>
           </a:xfrm>
           <a:prstGeom prst="rect">
             <a:avLst/>
@@ -2954,7 +3090,7 @@
         </p:spPr>
         <p:txBody>
           <a:bodyPr lIns="0" rIns="0" tIns="0" bIns="0" anchor="t">
-            <a:normAutofit/>
+            <a:normAutofit fontScale="50000"/>
           </a:bodyPr>
           <a:p>
             <a:pPr indent="0" defTabSz="914400">
@@ -2967,18 +3103,18 @@
               </a:tabLst>
             </a:pPr>
             <a:r>
-              <a:rPr b="1" lang="en-US" sz="3400" spc="-1" strike="noStrike">
+              <a:rPr b="1" lang="es-ES" sz="3400" spc="-1" strike="noStrike">
                 <a:solidFill>
                   <a:srgbClr val="0f2a44"/>
                 </a:solidFill>
                 <a:latin typeface="Georgia"/>
                 <a:ea typeface="Georgia"/>
               </a:rPr>
-              <a:t>Composite Stat-Boxplot</a:t>
+              <a:t>Composite Stat-Boxplot (Diagrama de caja estadístico compuesto)</a:t>
             </a:r>
             <a:endParaRPr b="0" lang="es-ES" sz="3400" spc="-1" strike="noStrike">
               <a:solidFill>
-                <a:schemeClr val="dk1"/>
+                <a:srgbClr val="000000"/>
               </a:solidFill>
               <a:latin typeface="Arial"/>
             </a:endParaRPr>
@@ -2994,7 +3130,7 @@
         <p:spPr>
           <a:xfrm>
             <a:off x="816120" y="1996920"/>
-            <a:ext cx="3380040" cy="2730600"/>
+            <a:ext cx="3378960" cy="2729520"/>
           </a:xfrm>
           <a:prstGeom prst="roundRect">
             <a:avLst>
@@ -3022,6 +3158,11 @@
             <a:noAutofit/>
           </a:bodyPr>
           <a:p>
+            <a:pPr>
+              <a:lnSpc>
+                <a:spcPct val="100000"/>
+              </a:lnSpc>
+            </a:pPr>
             <a:endParaRPr b="0" lang="es-ES" sz="1800" spc="-1" strike="noStrike">
               <a:solidFill>
                 <a:srgbClr val="000000"/>
@@ -3040,7 +3181,7 @@
         <p:spPr>
           <a:xfrm>
             <a:off x="1075320" y="2256120"/>
-            <a:ext cx="2947320" cy="268920"/>
+            <a:ext cx="2946240" cy="267840"/>
           </a:xfrm>
           <a:prstGeom prst="rect">
             <a:avLst/>
@@ -3070,7 +3211,7 @@
               </a:tabLst>
             </a:pPr>
             <a:r>
-              <a:rPr b="1" lang="en-US" sz="1600" spc="-1" strike="noStrike">
+              <a:rPr b="1" lang="es-ES" sz="1600" spc="-1" strike="noStrike">
                 <a:solidFill>
                   <a:srgbClr val="0b5394"/>
                 </a:solidFill>
@@ -3097,7 +3238,7 @@
         <p:spPr>
           <a:xfrm>
             <a:off x="1075320" y="2601720"/>
-            <a:ext cx="2947320" cy="1091880"/>
+            <a:ext cx="2946240" cy="1090800"/>
           </a:xfrm>
           <a:prstGeom prst="rect">
             <a:avLst/>
@@ -3127,7 +3268,7 @@
               </a:tabLst>
             </a:pPr>
             <a:r>
-              <a:rPr b="0" lang="en-US" sz="1500" spc="-1" strike="noStrike">
+              <a:rPr b="0" lang="es-ES" sz="1500" spc="-1" strike="noStrike">
                 <a:solidFill>
                   <a:srgbClr val="1b2733"/>
                 </a:solidFill>
@@ -3154,7 +3295,7 @@
         <p:spPr>
           <a:xfrm>
             <a:off x="4405680" y="1996920"/>
-            <a:ext cx="3380040" cy="2730600"/>
+            <a:ext cx="3378960" cy="2729520"/>
           </a:xfrm>
           <a:prstGeom prst="roundRect">
             <a:avLst>
@@ -3182,6 +3323,11 @@
             <a:noAutofit/>
           </a:bodyPr>
           <a:p>
+            <a:pPr>
+              <a:lnSpc>
+                <a:spcPct val="100000"/>
+              </a:lnSpc>
+            </a:pPr>
             <a:endParaRPr b="0" lang="es-ES" sz="1800" spc="-1" strike="noStrike">
               <a:solidFill>
                 <a:srgbClr val="000000"/>
@@ -3200,7 +3346,7 @@
         <p:spPr>
           <a:xfrm>
             <a:off x="4665240" y="2256120"/>
-            <a:ext cx="2947320" cy="268920"/>
+            <a:ext cx="2946240" cy="267840"/>
           </a:xfrm>
           <a:prstGeom prst="rect">
             <a:avLst/>
@@ -3230,7 +3376,7 @@
               </a:tabLst>
             </a:pPr>
             <a:r>
-              <a:rPr b="1" lang="en-US" sz="1600" spc="-1" strike="noStrike">
+              <a:rPr b="1" lang="es-ES" sz="1600" spc="-1" strike="noStrike">
                 <a:solidFill>
                   <a:srgbClr val="b4530f"/>
                 </a:solidFill>
@@ -3257,7 +3403,7 @@
         <p:spPr>
           <a:xfrm>
             <a:off x="4665240" y="2601720"/>
-            <a:ext cx="2947320" cy="1091880"/>
+            <a:ext cx="2946240" cy="1090800"/>
           </a:xfrm>
           <a:prstGeom prst="rect">
             <a:avLst/>
@@ -3287,7 +3433,7 @@
               </a:tabLst>
             </a:pPr>
             <a:r>
-              <a:rPr b="0" lang="en-US" sz="1500" spc="-1" strike="noStrike">
+              <a:rPr b="0" lang="es-ES" sz="1500" spc="-1" strike="noStrike">
                 <a:solidFill>
                   <a:srgbClr val="1b2733"/>
                 </a:solidFill>
@@ -3314,7 +3460,7 @@
         <p:spPr>
           <a:xfrm>
             <a:off x="7995600" y="1996920"/>
-            <a:ext cx="3380040" cy="2730600"/>
+            <a:ext cx="3378960" cy="2729520"/>
           </a:xfrm>
           <a:prstGeom prst="roundRect">
             <a:avLst>
@@ -3342,6 +3488,11 @@
             <a:noAutofit/>
           </a:bodyPr>
           <a:p>
+            <a:pPr>
+              <a:lnSpc>
+                <a:spcPct val="100000"/>
+              </a:lnSpc>
+            </a:pPr>
             <a:endParaRPr b="0" lang="es-ES" sz="1800" spc="-1" strike="noStrike">
               <a:solidFill>
                 <a:srgbClr val="000000"/>
@@ -3360,7 +3511,7 @@
         <p:spPr>
           <a:xfrm>
             <a:off x="8255160" y="2256120"/>
-            <a:ext cx="2947320" cy="268920"/>
+            <a:ext cx="2946240" cy="267840"/>
           </a:xfrm>
           <a:prstGeom prst="rect">
             <a:avLst/>
@@ -3390,7 +3541,7 @@
               </a:tabLst>
             </a:pPr>
             <a:r>
-              <a:rPr b="1" lang="en-US" sz="1600" spc="-1" strike="noStrike">
+              <a:rPr b="1" lang="es-ES" sz="1600" spc="-1" strike="noStrike">
                 <a:solidFill>
                   <a:srgbClr val="0f2a44"/>
                 </a:solidFill>
@@ -3417,7 +3568,7 @@
         <p:spPr>
           <a:xfrm>
             <a:off x="8255160" y="2601720"/>
-            <a:ext cx="2947320" cy="1891800"/>
+            <a:ext cx="2946240" cy="1890720"/>
           </a:xfrm>
           <a:prstGeom prst="rect">
             <a:avLst/>
@@ -3447,7 +3598,7 @@
               </a:tabLst>
             </a:pPr>
             <a:r>
-              <a:rPr b="0" lang="en-US" sz="1500" spc="-1" strike="noStrike">
+              <a:rPr b="0" lang="es-ES" sz="1500" spc="-1" strike="noStrike">
                 <a:solidFill>
                   <a:srgbClr val="1b2733"/>
                 </a:solidFill>
@@ -3474,7 +3625,7 @@
         <p:spPr>
           <a:xfrm>
             <a:off x="812880" y="6238440"/>
-            <a:ext cx="10883160" cy="238320"/>
+            <a:ext cx="10882080" cy="237240"/>
           </a:xfrm>
           <a:prstGeom prst="rect">
             <a:avLst/>
@@ -3504,7 +3655,7 @@
               </a:tabLst>
             </a:pPr>
             <a:r>
-              <a:rPr b="0" lang="en-US" sz="1200" spc="-1" strike="noStrike">
+              <a:rPr b="0" lang="es-ES" sz="1200" spc="-1" strike="noStrike">
                 <a:solidFill>
                   <a:srgbClr val="5b6672"/>
                 </a:solidFill>
@@ -3572,7 +3723,7 @@
         <p:spPr>
           <a:xfrm>
             <a:off x="812880" y="812880"/>
-            <a:ext cx="10883160" cy="751320"/>
+            <a:ext cx="10882080" cy="750240"/>
           </a:xfrm>
           <a:prstGeom prst="rect">
             <a:avLst/>
@@ -3604,11 +3755,11 @@
                 <a:latin typeface="Georgia"/>
                 <a:ea typeface="Georgia"/>
               </a:rPr>
-              <a:t>Café: la mediana va de 0,95 a 1,21 t/ha entre departamentos; la diferencia es clara pero de efecto pequeño (ε² = 0,07)</a:t>
+              <a:t>Café: la mediana va de 0,95 a 1,21 t/ha entre departamentos; la diferencia es clara pero de efecto pequeño </a:t>
             </a:r>
             <a:endParaRPr b="0" lang="es-ES" sz="2600" spc="-1" strike="noStrike">
               <a:solidFill>
-                <a:schemeClr val="dk1"/>
+                <a:srgbClr val="000000"/>
               </a:solidFill>
               <a:latin typeface="Arial"/>
             </a:endParaRPr>
@@ -3624,7 +3775,7 @@
         <p:spPr>
           <a:xfrm>
             <a:off x="812880" y="1767600"/>
-            <a:ext cx="6730560" cy="3041280"/>
+            <a:ext cx="6729480" cy="3040200"/>
           </a:xfrm>
           <a:prstGeom prst="roundRect">
             <a:avLst>
@@ -3649,6 +3800,11 @@
             <a:noAutofit/>
           </a:bodyPr>
           <a:p>
+            <a:pPr>
+              <a:lnSpc>
+                <a:spcPct val="100000"/>
+              </a:lnSpc>
+            </a:pPr>
             <a:endParaRPr b="0" lang="es-ES" sz="1800" spc="-1" strike="noStrike">
               <a:solidFill>
                 <a:srgbClr val="000000"/>
@@ -3667,7 +3823,7 @@
         <p:spPr>
           <a:xfrm>
             <a:off x="819000" y="1774080"/>
-            <a:ext cx="6717960" cy="3028680"/>
+            <a:ext cx="6716880" cy="3027600"/>
           </a:xfrm>
           <a:prstGeom prst="roundRect">
             <a:avLst>
@@ -3694,6 +3850,11 @@
             <a:noAutofit/>
           </a:bodyPr>
           <a:p>
+            <a:pPr>
+              <a:lnSpc>
+                <a:spcPct val="100000"/>
+              </a:lnSpc>
+            </a:pPr>
             <a:endParaRPr b="0" lang="es-ES" sz="1800" spc="-1" strike="noStrike">
               <a:solidFill>
                 <a:srgbClr val="000000"/>
@@ -3712,7 +3873,7 @@
         <p:spPr>
           <a:xfrm>
             <a:off x="816120" y="1770840"/>
-            <a:ext cx="6724440" cy="3034800"/>
+            <a:ext cx="6723360" cy="3033720"/>
           </a:xfrm>
           <a:prstGeom prst="roundRect">
             <a:avLst>
@@ -3738,6 +3899,11 @@
             <a:noAutofit/>
           </a:bodyPr>
           <a:p>
+            <a:pPr>
+              <a:lnSpc>
+                <a:spcPct val="100000"/>
+              </a:lnSpc>
+            </a:pPr>
             <a:endParaRPr b="0" lang="es-ES" sz="1800" spc="-1" strike="noStrike">
               <a:solidFill>
                 <a:srgbClr val="000000"/>
@@ -3756,7 +3922,7 @@
         <p:spPr>
           <a:xfrm>
             <a:off x="7797960" y="1767600"/>
-            <a:ext cx="3688560" cy="2104920"/>
+            <a:ext cx="3687480" cy="2103840"/>
           </a:xfrm>
           <a:prstGeom prst="rect">
             <a:avLst/>
@@ -3786,14 +3952,14 @@
               </a:tabLst>
             </a:pPr>
             <a:r>
-              <a:rPr b="0" lang="en-US" sz="1300" spc="-1" strike="noStrike">
+              <a:rPr b="0" lang="es-ES" sz="1300" spc="-1" strike="noStrike">
                 <a:solidFill>
                   <a:srgbClr val="1b2733"/>
                 </a:solidFill>
                 <a:latin typeface="Arial"/>
                 <a:ea typeface="Arial"/>
               </a:rPr>
-              <a:t>Antioquia lidera (1,21 t/ha) y Boyacá queda último (0,95). Kruskal-Wallis detecta diferencias entre departamentos (H = 182,5; p &lt; 0,001), pero el departamento explica solo cerca del 7 % de la variación en rangos. La media casi coincide con la mediana (brecha de 0,01 a 0,08 t/ha): no hay asimetría marcada. Los rendimientos están parcialmente redondeados. Descriptivo.</a:t>
+              <a:t>Antioquia lidera (1,21 t/ha) y Boyacá queda último (0,95). Kruskal-Wallis detecta diferencias entre departamentos, pero el departamento explica solo cerca del 7 % de la variación en rangos. La media casi coincide con la mediana (brecha de 0,01 a 0,08 t/ha): no hay asimetría marcada. Los rendimientos están parcialmente redondeados. Descriptivo.</a:t>
             </a:r>
             <a:endParaRPr b="0" lang="es-ES" sz="1300" spc="-1" strike="noStrike">
               <a:solidFill>
@@ -3813,7 +3979,7 @@
         <p:spPr>
           <a:xfrm>
             <a:off x="7797960" y="3999960"/>
-            <a:ext cx="3688560" cy="238320"/>
+            <a:ext cx="3687480" cy="237240"/>
           </a:xfrm>
           <a:prstGeom prst="rect">
             <a:avLst/>
@@ -3843,7 +4009,7 @@
               </a:tabLst>
             </a:pPr>
             <a:r>
-              <a:rPr b="0" lang="en-US" sz="1200" spc="-1" strike="noStrike">
+              <a:rPr b="0" lang="es-ES" sz="1200" spc="-1" strike="noStrike">
                 <a:solidFill>
                   <a:srgbClr val="5b6672"/>
                 </a:solidFill>
@@ -3870,7 +4036,7 @@
         <p:spPr>
           <a:xfrm>
             <a:off x="7797960" y="4365720"/>
-            <a:ext cx="3580920" cy="680040"/>
+            <a:ext cx="3579840" cy="678960"/>
           </a:xfrm>
           <a:prstGeom prst="roundRect">
             <a:avLst>
@@ -3904,7 +4070,7 @@
               </a:tabLst>
             </a:pPr>
             <a:r>
-              <a:rPr b="0" lang="en-US" sz="1200" spc="-1" strike="noStrike">
+              <a:rPr b="0" lang="es-ES" sz="1200" spc="-1" strike="noStrike">
                 <a:solidFill>
                   <a:srgbClr val="e8eef4"/>
                 </a:solidFill>
@@ -3931,7 +4097,7 @@
         <p:spPr>
           <a:xfrm>
             <a:off x="7797960" y="5198760"/>
-            <a:ext cx="3688560" cy="238320"/>
+            <a:ext cx="3687480" cy="237240"/>
           </a:xfrm>
           <a:prstGeom prst="rect">
             <a:avLst/>
@@ -3961,7 +4127,7 @@
               </a:tabLst>
             </a:pPr>
             <a:r>
-              <a:rPr b="1" lang="en-US" sz="1200" spc="-1" strike="noStrike">
+              <a:rPr b="1" lang="es-ES" sz="1200" spc="-1" strike="noStrike">
                 <a:solidFill>
                   <a:srgbClr val="b4530f"/>
                 </a:solidFill>
@@ -3988,7 +4154,7 @@
         <p:spPr>
           <a:xfrm>
             <a:off x="812880" y="6238440"/>
-            <a:ext cx="10883160" cy="238320"/>
+            <a:ext cx="10882080" cy="237240"/>
           </a:xfrm>
           <a:prstGeom prst="rect">
             <a:avLst/>
@@ -4018,7 +4184,7 @@
               </a:tabLst>
             </a:pPr>
             <a:r>
-              <a:rPr b="0" lang="en-US" sz="1200" spc="-1" strike="noStrike">
+              <a:rPr b="0" lang="es-ES" sz="1200" spc="-1" strike="noStrike">
                 <a:solidFill>
                   <a:srgbClr val="5b6672"/>
                 </a:solidFill>
@@ -4082,7 +4248,7 @@
         <p:spPr>
           <a:xfrm>
             <a:off x="812880" y="812880"/>
-            <a:ext cx="10883160" cy="273960"/>
+            <a:ext cx="10882080" cy="272880"/>
           </a:xfrm>
           <a:prstGeom prst="rect">
             <a:avLst/>
@@ -4112,7 +4278,7 @@
               </a:tabLst>
             </a:pPr>
             <a:r>
-              <a:rPr b="1" lang="en-US" sz="1400" spc="-1" strike="noStrike">
+              <a:rPr b="1" lang="es-ES" sz="1400" spc="-1" strike="noStrike">
                 <a:solidFill>
                   <a:srgbClr val="b4530f"/>
                 </a:solidFill>
@@ -4143,7 +4309,7 @@
         <p:spPr>
           <a:xfrm>
             <a:off x="812880" y="1290240"/>
-            <a:ext cx="10883160" cy="500040"/>
+            <a:ext cx="10882080" cy="498960"/>
           </a:xfrm>
           <a:prstGeom prst="rect">
             <a:avLst/>
@@ -4162,24 +4328,30 @@
               <a:lnSpc>
                 <a:spcPts val="3739"/>
               </a:lnSpc>
+              <a:spcBef>
+                <a:spcPts val="1191"/>
+              </a:spcBef>
+              <a:spcAft>
+                <a:spcPts val="992"/>
+              </a:spcAft>
               <a:buNone/>
               <a:tabLst>
                 <a:tab algn="l" pos="0"/>
               </a:tabLst>
             </a:pPr>
             <a:r>
-              <a:rPr b="1" lang="en-US" sz="3400" spc="-1" strike="noStrike">
+              <a:rPr b="1" lang="es-ES" sz="3400" spc="-1" strike="noStrike">
                 <a:solidFill>
                   <a:srgbClr val="0f2a44"/>
                 </a:solidFill>
                 <a:latin typeface="Georgia"/>
                 <a:ea typeface="Georgia"/>
               </a:rPr>
-              <a:t>Half-Eye Plot</a:t>
+              <a:t>Half-Eye Plot (Gráfico de medio ojo)</a:t>
             </a:r>
             <a:endParaRPr b="0" lang="es-ES" sz="3400" spc="-1" strike="noStrike">
               <a:solidFill>
-                <a:schemeClr val="dk1"/>
+                <a:srgbClr val="000000"/>
               </a:solidFill>
               <a:latin typeface="Arial"/>
             </a:endParaRPr>
@@ -4195,7 +4367,7 @@
         <p:spPr>
           <a:xfrm>
             <a:off x="816120" y="1996920"/>
-            <a:ext cx="3380040" cy="2463840"/>
+            <a:ext cx="3378960" cy="2462760"/>
           </a:xfrm>
           <a:prstGeom prst="roundRect">
             <a:avLst>
@@ -4223,6 +4395,11 @@
             <a:noAutofit/>
           </a:bodyPr>
           <a:p>
+            <a:pPr>
+              <a:lnSpc>
+                <a:spcPct val="100000"/>
+              </a:lnSpc>
+            </a:pPr>
             <a:endParaRPr b="0" lang="es-ES" sz="1800" spc="-1" strike="noStrike">
               <a:solidFill>
                 <a:srgbClr val="000000"/>
@@ -4241,7 +4418,7 @@
         <p:spPr>
           <a:xfrm>
             <a:off x="1075320" y="2256120"/>
-            <a:ext cx="2947320" cy="268920"/>
+            <a:ext cx="2946240" cy="267840"/>
           </a:xfrm>
           <a:prstGeom prst="rect">
             <a:avLst/>
@@ -4271,7 +4448,7 @@
               </a:tabLst>
             </a:pPr>
             <a:r>
-              <a:rPr b="1" lang="en-US" sz="1600" spc="-1" strike="noStrike">
+              <a:rPr b="1" lang="es-ES" sz="1600" spc="-1" strike="noStrike">
                 <a:solidFill>
                   <a:srgbClr val="0b5394"/>
                 </a:solidFill>
@@ -4298,7 +4475,7 @@
         <p:spPr>
           <a:xfrm>
             <a:off x="1075320" y="2601720"/>
-            <a:ext cx="2947320" cy="1358640"/>
+            <a:ext cx="2946240" cy="1357560"/>
           </a:xfrm>
           <a:prstGeom prst="rect">
             <a:avLst/>
@@ -4328,7 +4505,7 @@
               </a:tabLst>
             </a:pPr>
             <a:r>
-              <a:rPr b="0" lang="en-US" sz="1500" spc="-1" strike="noStrike">
+              <a:rPr b="0" lang="es-ES" sz="1500" spc="-1" strike="noStrike">
                 <a:solidFill>
                   <a:srgbClr val="1b2733"/>
                 </a:solidFill>
@@ -4355,7 +4532,7 @@
         <p:spPr>
           <a:xfrm>
             <a:off x="4405680" y="1996920"/>
-            <a:ext cx="3380040" cy="2463840"/>
+            <a:ext cx="3378960" cy="2462760"/>
           </a:xfrm>
           <a:prstGeom prst="roundRect">
             <a:avLst>
@@ -4383,6 +4560,11 @@
             <a:noAutofit/>
           </a:bodyPr>
           <a:p>
+            <a:pPr>
+              <a:lnSpc>
+                <a:spcPct val="100000"/>
+              </a:lnSpc>
+            </a:pPr>
             <a:endParaRPr b="0" lang="es-ES" sz="1800" spc="-1" strike="noStrike">
               <a:solidFill>
                 <a:srgbClr val="000000"/>
@@ -4401,7 +4583,7 @@
         <p:spPr>
           <a:xfrm>
             <a:off x="4665240" y="2256120"/>
-            <a:ext cx="2947320" cy="268920"/>
+            <a:ext cx="2946240" cy="267840"/>
           </a:xfrm>
           <a:prstGeom prst="rect">
             <a:avLst/>
@@ -4431,7 +4613,7 @@
               </a:tabLst>
             </a:pPr>
             <a:r>
-              <a:rPr b="1" lang="en-US" sz="1600" spc="-1" strike="noStrike">
+              <a:rPr b="1" lang="es-ES" sz="1600" spc="-1" strike="noStrike">
                 <a:solidFill>
                   <a:srgbClr val="b4530f"/>
                 </a:solidFill>
@@ -4458,7 +4640,7 @@
         <p:spPr>
           <a:xfrm>
             <a:off x="4665240" y="2601720"/>
-            <a:ext cx="2947320" cy="1358640"/>
+            <a:ext cx="2946240" cy="1357560"/>
           </a:xfrm>
           <a:prstGeom prst="rect">
             <a:avLst/>
@@ -4488,7 +4670,7 @@
               </a:tabLst>
             </a:pPr>
             <a:r>
-              <a:rPr b="0" lang="en-US" sz="1500" spc="-1" strike="noStrike">
+              <a:rPr b="0" lang="es-ES" sz="1500" spc="-1" strike="noStrike">
                 <a:solidFill>
                   <a:srgbClr val="1b2733"/>
                 </a:solidFill>
@@ -4515,7 +4697,7 @@
         <p:spPr>
           <a:xfrm>
             <a:off x="7995600" y="1996920"/>
-            <a:ext cx="3380040" cy="2463840"/>
+            <a:ext cx="3378960" cy="2462760"/>
           </a:xfrm>
           <a:prstGeom prst="roundRect">
             <a:avLst>
@@ -4543,6 +4725,11 @@
             <a:noAutofit/>
           </a:bodyPr>
           <a:p>
+            <a:pPr>
+              <a:lnSpc>
+                <a:spcPct val="100000"/>
+              </a:lnSpc>
+            </a:pPr>
             <a:endParaRPr b="0" lang="es-ES" sz="1800" spc="-1" strike="noStrike">
               <a:solidFill>
                 <a:srgbClr val="000000"/>
@@ -4561,7 +4748,7 @@
         <p:spPr>
           <a:xfrm>
             <a:off x="8255160" y="2256120"/>
-            <a:ext cx="2947320" cy="268920"/>
+            <a:ext cx="2946240" cy="267840"/>
           </a:xfrm>
           <a:prstGeom prst="rect">
             <a:avLst/>
@@ -4591,7 +4778,7 @@
               </a:tabLst>
             </a:pPr>
             <a:r>
-              <a:rPr b="1" lang="en-US" sz="1600" spc="-1" strike="noStrike">
+              <a:rPr b="1" lang="es-ES" sz="1600" spc="-1" strike="noStrike">
                 <a:solidFill>
                   <a:srgbClr val="0f2a44"/>
                 </a:solidFill>
@@ -4618,7 +4805,7 @@
         <p:spPr>
           <a:xfrm>
             <a:off x="8255160" y="2601720"/>
-            <a:ext cx="2947320" cy="1625400"/>
+            <a:ext cx="2946240" cy="1624320"/>
           </a:xfrm>
           <a:prstGeom prst="rect">
             <a:avLst/>
@@ -4648,7 +4835,7 @@
               </a:tabLst>
             </a:pPr>
             <a:r>
-              <a:rPr b="0" lang="en-US" sz="1500" spc="-1" strike="noStrike">
+              <a:rPr b="0" lang="es-ES" sz="1500" spc="-1" strike="noStrike">
                 <a:solidFill>
                   <a:srgbClr val="1b2733"/>
                 </a:solidFill>
@@ -4675,7 +4862,7 @@
         <p:spPr>
           <a:xfrm>
             <a:off x="812880" y="6238440"/>
-            <a:ext cx="10883160" cy="238320"/>
+            <a:ext cx="10882080" cy="237240"/>
           </a:xfrm>
           <a:prstGeom prst="rect">
             <a:avLst/>
@@ -4705,7 +4892,7 @@
               </a:tabLst>
             </a:pPr>
             <a:r>
-              <a:rPr b="0" lang="en-US" sz="1200" spc="-1" strike="noStrike">
+              <a:rPr b="0" lang="es-ES" sz="1200" spc="-1" strike="noStrike">
                 <a:solidFill>
                   <a:srgbClr val="5b6672"/>
                 </a:solidFill>
@@ -4773,7 +4960,7 @@
         <p:spPr>
           <a:xfrm>
             <a:off x="812880" y="812880"/>
-            <a:ext cx="10883160" cy="751320"/>
+            <a:ext cx="10882080" cy="750240"/>
           </a:xfrm>
           <a:prstGeom prst="rect">
             <a:avLst/>
@@ -4798,7 +4985,7 @@
               </a:tabLst>
             </a:pPr>
             <a:r>
-              <a:rPr b="1" lang="en-US" sz="2600" spc="-1" strike="noStrike">
+              <a:rPr b="1" lang="es-ES" sz="2600" spc="-1" strike="noStrike">
                 <a:solidFill>
                   <a:srgbClr val="0f2a44"/>
                 </a:solidFill>
@@ -4809,7 +4996,7 @@
             </a:r>
             <a:endParaRPr b="0" lang="es-ES" sz="2600" spc="-1" strike="noStrike">
               <a:solidFill>
-                <a:schemeClr val="dk1"/>
+                <a:srgbClr val="000000"/>
               </a:solidFill>
               <a:latin typeface="Arial"/>
             </a:endParaRPr>
@@ -4825,7 +5012,7 @@
         <p:spPr>
           <a:xfrm>
             <a:off x="812880" y="1767600"/>
-            <a:ext cx="6730560" cy="3193560"/>
+            <a:ext cx="6729480" cy="3192480"/>
           </a:xfrm>
           <a:prstGeom prst="roundRect">
             <a:avLst>
@@ -4850,6 +5037,11 @@
             <a:noAutofit/>
           </a:bodyPr>
           <a:p>
+            <a:pPr>
+              <a:lnSpc>
+                <a:spcPct val="100000"/>
+              </a:lnSpc>
+            </a:pPr>
             <a:endParaRPr b="0" lang="es-ES" sz="1800" spc="-1" strike="noStrike">
               <a:solidFill>
                 <a:srgbClr val="000000"/>
@@ -4867,8 +5059,8 @@
         </p:nvSpPr>
         <p:spPr>
           <a:xfrm>
-            <a:off x="819000" y="1774080"/>
-            <a:ext cx="6717960" cy="3180960"/>
+            <a:off x="789480" y="1864800"/>
+            <a:ext cx="6716880" cy="3179880"/>
           </a:xfrm>
           <a:prstGeom prst="roundRect">
             <a:avLst>
@@ -4895,6 +5087,11 @@
             <a:noAutofit/>
           </a:bodyPr>
           <a:p>
+            <a:pPr>
+              <a:lnSpc>
+                <a:spcPct val="100000"/>
+              </a:lnSpc>
+            </a:pPr>
             <a:endParaRPr b="0" lang="es-ES" sz="1800" spc="-1" strike="noStrike">
               <a:solidFill>
                 <a:srgbClr val="000000"/>
@@ -4913,7 +5110,7 @@
         <p:spPr>
           <a:xfrm>
             <a:off x="816120" y="1770840"/>
-            <a:ext cx="6724440" cy="3187440"/>
+            <a:ext cx="6723360" cy="3186360"/>
           </a:xfrm>
           <a:prstGeom prst="roundRect">
             <a:avLst>
@@ -4939,6 +5136,11 @@
             <a:noAutofit/>
           </a:bodyPr>
           <a:p>
+            <a:pPr>
+              <a:lnSpc>
+                <a:spcPct val="100000"/>
+              </a:lnSpc>
+            </a:pPr>
             <a:endParaRPr b="0" lang="es-ES" sz="1800" spc="-1" strike="noStrike">
               <a:solidFill>
                 <a:srgbClr val="000000"/>
@@ -4957,7 +5159,7 @@
         <p:spPr>
           <a:xfrm>
             <a:off x="7797960" y="1767600"/>
-            <a:ext cx="3688560" cy="2104920"/>
+            <a:ext cx="3687480" cy="2103840"/>
           </a:xfrm>
           <a:prstGeom prst="rect">
             <a:avLst/>
@@ -4987,7 +5189,7 @@
               </a:tabLst>
             </a:pPr>
             <a:r>
-              <a:rPr b="0" lang="en-US" sz="1300" spc="-1" strike="noStrike">
+              <a:rPr b="0" lang="es-ES" sz="1300" spc="-1" strike="noStrike">
                 <a:solidFill>
                   <a:srgbClr val="1b2733"/>
                 </a:solidFill>
@@ -5014,7 +5216,7 @@
         <p:spPr>
           <a:xfrm>
             <a:off x="7797960" y="3999960"/>
-            <a:ext cx="3688560" cy="238320"/>
+            <a:ext cx="3687480" cy="237240"/>
           </a:xfrm>
           <a:prstGeom prst="rect">
             <a:avLst/>
@@ -5044,7 +5246,7 @@
               </a:tabLst>
             </a:pPr>
             <a:r>
-              <a:rPr b="0" lang="en-US" sz="1200" spc="-1" strike="noStrike">
+              <a:rPr b="0" lang="es-ES" sz="1200" spc="-1" strike="noStrike">
                 <a:solidFill>
                   <a:srgbClr val="5b6672"/>
                 </a:solidFill>
@@ -5071,7 +5273,7 @@
         <p:spPr>
           <a:xfrm>
             <a:off x="7797960" y="4365720"/>
-            <a:ext cx="3580920" cy="680040"/>
+            <a:ext cx="3579840" cy="678960"/>
           </a:xfrm>
           <a:prstGeom prst="roundRect">
             <a:avLst>
@@ -5105,7 +5307,7 @@
               </a:tabLst>
             </a:pPr>
             <a:r>
-              <a:rPr b="0" lang="en-US" sz="1200" spc="-1" strike="noStrike">
+              <a:rPr b="0" lang="es-ES" sz="1200" spc="-1" strike="noStrike">
                 <a:solidFill>
                   <a:srgbClr val="e8eef4"/>
                 </a:solidFill>
@@ -5132,7 +5334,7 @@
         <p:spPr>
           <a:xfrm>
             <a:off x="7797960" y="5198760"/>
-            <a:ext cx="3688560" cy="238320"/>
+            <a:ext cx="3687480" cy="237240"/>
           </a:xfrm>
           <a:prstGeom prst="rect">
             <a:avLst/>
@@ -5162,7 +5364,7 @@
               </a:tabLst>
             </a:pPr>
             <a:r>
-              <a:rPr b="1" lang="en-US" sz="1200" spc="-1" strike="noStrike">
+              <a:rPr b="1" lang="es-ES" sz="1200" spc="-1" strike="noStrike">
                 <a:solidFill>
                   <a:srgbClr val="b4530f"/>
                 </a:solidFill>
@@ -5189,7 +5391,7 @@
         <p:spPr>
           <a:xfrm>
             <a:off x="812880" y="6238440"/>
-            <a:ext cx="10883160" cy="238320"/>
+            <a:ext cx="10882080" cy="237240"/>
           </a:xfrm>
           <a:prstGeom prst="rect">
             <a:avLst/>
@@ -5219,7 +5421,7 @@
               </a:tabLst>
             </a:pPr>
             <a:r>
-              <a:rPr b="0" lang="en-US" sz="1200" spc="-1" strike="noStrike">
+              <a:rPr b="0" lang="es-ES" sz="1200" spc="-1" strike="noStrike">
                 <a:solidFill>
                   <a:srgbClr val="5b6672"/>
                 </a:solidFill>
@@ -5283,7 +5485,7 @@
         <p:spPr>
           <a:xfrm>
             <a:off x="812880" y="812880"/>
-            <a:ext cx="10883160" cy="273960"/>
+            <a:ext cx="10882080" cy="272880"/>
           </a:xfrm>
           <a:prstGeom prst="rect">
             <a:avLst/>
@@ -5313,7 +5515,7 @@
               </a:tabLst>
             </a:pPr>
             <a:r>
-              <a:rPr b="1" lang="en-US" sz="1400" spc="-1" strike="noStrike">
+              <a:rPr b="1" lang="es-ES" sz="1400" spc="-1" strike="noStrike">
                 <a:solidFill>
                   <a:srgbClr val="b4530f"/>
                 </a:solidFill>
@@ -5344,7 +5546,7 @@
         <p:spPr>
           <a:xfrm>
             <a:off x="812880" y="1290240"/>
-            <a:ext cx="10883160" cy="500040"/>
+            <a:ext cx="10882080" cy="498960"/>
           </a:xfrm>
           <a:prstGeom prst="rect">
             <a:avLst/>
@@ -5369,7 +5571,7 @@
               </a:tabLst>
             </a:pPr>
             <a:r>
-              <a:rPr b="1" lang="en-US" sz="3400" spc="-1" strike="noStrike">
+              <a:rPr b="1" lang="es-ES" sz="3400" spc="-1" strike="noStrike">
                 <a:solidFill>
                   <a:srgbClr val="0f2a44"/>
                 </a:solidFill>
@@ -5380,7 +5582,7 @@
             </a:r>
             <a:endParaRPr b="0" lang="es-ES" sz="3400" spc="-1" strike="noStrike">
               <a:solidFill>
-                <a:schemeClr val="dk1"/>
+                <a:srgbClr val="000000"/>
               </a:solidFill>
               <a:latin typeface="Arial"/>
             </a:endParaRPr>
@@ -5396,7 +5598,7 @@
         <p:spPr>
           <a:xfrm>
             <a:off x="816120" y="1996920"/>
-            <a:ext cx="3380040" cy="2197080"/>
+            <a:ext cx="3378960" cy="2196000"/>
           </a:xfrm>
           <a:prstGeom prst="roundRect">
             <a:avLst>
@@ -5424,6 +5626,11 @@
             <a:noAutofit/>
           </a:bodyPr>
           <a:p>
+            <a:pPr>
+              <a:lnSpc>
+                <a:spcPct val="100000"/>
+              </a:lnSpc>
+            </a:pPr>
             <a:endParaRPr b="0" lang="es-ES" sz="1800" spc="-1" strike="noStrike">
               <a:solidFill>
                 <a:srgbClr val="000000"/>
@@ -5442,7 +5649,7 @@
         <p:spPr>
           <a:xfrm>
             <a:off x="1075320" y="2256120"/>
-            <a:ext cx="2947320" cy="268920"/>
+            <a:ext cx="2946240" cy="267840"/>
           </a:xfrm>
           <a:prstGeom prst="rect">
             <a:avLst/>
@@ -5472,7 +5679,7 @@
               </a:tabLst>
             </a:pPr>
             <a:r>
-              <a:rPr b="1" lang="en-US" sz="1600" spc="-1" strike="noStrike">
+              <a:rPr b="1" lang="es-ES" sz="1600" spc="-1" strike="noStrike">
                 <a:solidFill>
                   <a:srgbClr val="0b5394"/>
                 </a:solidFill>
@@ -5499,7 +5706,7 @@
         <p:spPr>
           <a:xfrm>
             <a:off x="1075320" y="2601720"/>
-            <a:ext cx="2947320" cy="825120"/>
+            <a:ext cx="2946240" cy="824040"/>
           </a:xfrm>
           <a:prstGeom prst="rect">
             <a:avLst/>
@@ -5529,7 +5736,7 @@
               </a:tabLst>
             </a:pPr>
             <a:r>
-              <a:rPr b="0" lang="en-US" sz="1500" spc="-1" strike="noStrike">
+              <a:rPr b="0" lang="es-ES" sz="1500" spc="-1" strike="noStrike">
                 <a:solidFill>
                   <a:srgbClr val="1b2733"/>
                 </a:solidFill>
@@ -5556,7 +5763,7 @@
         <p:spPr>
           <a:xfrm>
             <a:off x="4405680" y="1996920"/>
-            <a:ext cx="3380040" cy="2197080"/>
+            <a:ext cx="3378960" cy="2196000"/>
           </a:xfrm>
           <a:prstGeom prst="roundRect">
             <a:avLst>
@@ -5584,6 +5791,11 @@
             <a:noAutofit/>
           </a:bodyPr>
           <a:p>
+            <a:pPr>
+              <a:lnSpc>
+                <a:spcPct val="100000"/>
+              </a:lnSpc>
+            </a:pPr>
             <a:endParaRPr b="0" lang="es-ES" sz="1800" spc="-1" strike="noStrike">
               <a:solidFill>
                 <a:srgbClr val="000000"/>
@@ -5602,7 +5814,7 @@
         <p:spPr>
           <a:xfrm>
             <a:off x="4665240" y="2256120"/>
-            <a:ext cx="2947320" cy="268920"/>
+            <a:ext cx="2946240" cy="267840"/>
           </a:xfrm>
           <a:prstGeom prst="rect">
             <a:avLst/>
@@ -5632,7 +5844,7 @@
               </a:tabLst>
             </a:pPr>
             <a:r>
-              <a:rPr b="1" lang="en-US" sz="1600" spc="-1" strike="noStrike">
+              <a:rPr b="1" lang="es-ES" sz="1600" spc="-1" strike="noStrike">
                 <a:solidFill>
                   <a:srgbClr val="b4530f"/>
                 </a:solidFill>
@@ -5659,7 +5871,7 @@
         <p:spPr>
           <a:xfrm>
             <a:off x="4665240" y="2601720"/>
-            <a:ext cx="2947320" cy="1358640"/>
+            <a:ext cx="2946240" cy="1357560"/>
           </a:xfrm>
           <a:prstGeom prst="rect">
             <a:avLst/>
@@ -5689,7 +5901,7 @@
               </a:tabLst>
             </a:pPr>
             <a:r>
-              <a:rPr b="0" lang="en-US" sz="1500" spc="-1" strike="noStrike">
+              <a:rPr b="0" lang="es-ES" sz="1500" spc="-1" strike="noStrike">
                 <a:solidFill>
                   <a:srgbClr val="1b2733"/>
                 </a:solidFill>
@@ -5716,7 +5928,7 @@
         <p:spPr>
           <a:xfrm>
             <a:off x="7995600" y="1996920"/>
-            <a:ext cx="3380040" cy="2197080"/>
+            <a:ext cx="3378960" cy="2196000"/>
           </a:xfrm>
           <a:prstGeom prst="roundRect">
             <a:avLst>
@@ -5744,6 +5956,11 @@
             <a:noAutofit/>
           </a:bodyPr>
           <a:p>
+            <a:pPr>
+              <a:lnSpc>
+                <a:spcPct val="100000"/>
+              </a:lnSpc>
+            </a:pPr>
             <a:endParaRPr b="0" lang="es-ES" sz="1800" spc="-1" strike="noStrike">
               <a:solidFill>
                 <a:srgbClr val="000000"/>
@@ -5762,7 +5979,7 @@
         <p:spPr>
           <a:xfrm>
             <a:off x="8255160" y="2256120"/>
-            <a:ext cx="2947320" cy="268920"/>
+            <a:ext cx="2946240" cy="267840"/>
           </a:xfrm>
           <a:prstGeom prst="rect">
             <a:avLst/>
@@ -5792,7 +6009,7 @@
               </a:tabLst>
             </a:pPr>
             <a:r>
-              <a:rPr b="1" lang="en-US" sz="1600" spc="-1" strike="noStrike">
+              <a:rPr b="1" lang="es-ES" sz="1600" spc="-1" strike="noStrike">
                 <a:solidFill>
                   <a:srgbClr val="0f2a44"/>
                 </a:solidFill>
@@ -5819,7 +6036,7 @@
         <p:spPr>
           <a:xfrm>
             <a:off x="8255160" y="2601720"/>
-            <a:ext cx="2947320" cy="1358640"/>
+            <a:ext cx="2946240" cy="1357560"/>
           </a:xfrm>
           <a:prstGeom prst="rect">
             <a:avLst/>
@@ -5849,7 +6066,7 @@
               </a:tabLst>
             </a:pPr>
             <a:r>
-              <a:rPr b="0" lang="en-US" sz="1500" spc="-1" strike="noStrike">
+              <a:rPr b="0" lang="es-ES" sz="1500" spc="-1" strike="noStrike">
                 <a:solidFill>
                   <a:srgbClr val="1b2733"/>
                 </a:solidFill>
@@ -5876,7 +6093,7 @@
         <p:spPr>
           <a:xfrm>
             <a:off x="812880" y="6238440"/>
-            <a:ext cx="10883160" cy="238320"/>
+            <a:ext cx="10882080" cy="237240"/>
           </a:xfrm>
           <a:prstGeom prst="rect">
             <a:avLst/>
@@ -5906,7 +6123,7 @@
               </a:tabLst>
             </a:pPr>
             <a:r>
-              <a:rPr b="0" lang="en-US" sz="1200" spc="-1" strike="noStrike">
+              <a:rPr b="0" lang="es-ES" sz="1200" spc="-1" strike="noStrike">
                 <a:solidFill>
                   <a:srgbClr val="5b6672"/>
                 </a:solidFill>
@@ -5974,7 +6191,7 @@
         <p:spPr>
           <a:xfrm>
             <a:off x="812880" y="812880"/>
-            <a:ext cx="10883160" cy="751320"/>
+            <a:ext cx="10882080" cy="750240"/>
           </a:xfrm>
           <a:prstGeom prst="rect">
             <a:avLst/>
@@ -5999,7 +6216,7 @@
               </a:tabLst>
             </a:pPr>
             <a:r>
-              <a:rPr b="1" lang="en-US" sz="2600" spc="-1" strike="noStrike">
+              <a:rPr b="1" lang="es-ES" sz="2600" spc="-1" strike="noStrike">
                 <a:solidFill>
                   <a:srgbClr val="0f2a44"/>
                 </a:solidFill>
@@ -6010,7 +6227,7 @@
             </a:r>
             <a:endParaRPr b="0" lang="es-ES" sz="2600" spc="-1" strike="noStrike">
               <a:solidFill>
-                <a:schemeClr val="dk1"/>
+                <a:srgbClr val="000000"/>
               </a:solidFill>
               <a:latin typeface="Arial"/>
             </a:endParaRPr>
@@ -6026,7 +6243,7 @@
         <p:spPr>
           <a:xfrm>
             <a:off x="812880" y="1767600"/>
-            <a:ext cx="6730560" cy="3492000"/>
+            <a:ext cx="6729480" cy="3490920"/>
           </a:xfrm>
           <a:prstGeom prst="roundRect">
             <a:avLst>
@@ -6051,6 +6268,11 @@
             <a:noAutofit/>
           </a:bodyPr>
           <a:p>
+            <a:pPr>
+              <a:lnSpc>
+                <a:spcPct val="100000"/>
+              </a:lnSpc>
+            </a:pPr>
             <a:endParaRPr b="0" lang="es-ES" sz="1800" spc="-1" strike="noStrike">
               <a:solidFill>
                 <a:srgbClr val="000000"/>
@@ -6069,7 +6291,7 @@
         <p:spPr>
           <a:xfrm>
             <a:off x="819000" y="1774080"/>
-            <a:ext cx="6717960" cy="3479400"/>
+            <a:ext cx="6716880" cy="3478320"/>
           </a:xfrm>
           <a:prstGeom prst="roundRect">
             <a:avLst>
@@ -6096,6 +6318,11 @@
             <a:noAutofit/>
           </a:bodyPr>
           <a:p>
+            <a:pPr>
+              <a:lnSpc>
+                <a:spcPct val="100000"/>
+              </a:lnSpc>
+            </a:pPr>
             <a:endParaRPr b="0" lang="es-ES" sz="1800" spc="-1" strike="noStrike">
               <a:solidFill>
                 <a:srgbClr val="000000"/>
@@ -6114,7 +6341,7 @@
         <p:spPr>
           <a:xfrm>
             <a:off x="816120" y="1770840"/>
-            <a:ext cx="6724440" cy="3485880"/>
+            <a:ext cx="6723360" cy="3484800"/>
           </a:xfrm>
           <a:prstGeom prst="roundRect">
             <a:avLst>
@@ -6140,6 +6367,11 @@
             <a:noAutofit/>
           </a:bodyPr>
           <a:p>
+            <a:pPr>
+              <a:lnSpc>
+                <a:spcPct val="100000"/>
+              </a:lnSpc>
+            </a:pPr>
             <a:endParaRPr b="0" lang="es-ES" sz="1800" spc="-1" strike="noStrike">
               <a:solidFill>
                 <a:srgbClr val="000000"/>
@@ -6158,7 +6390,7 @@
         <p:spPr>
           <a:xfrm>
             <a:off x="7797960" y="1767600"/>
-            <a:ext cx="3688560" cy="1642680"/>
+            <a:ext cx="3687480" cy="1641600"/>
           </a:xfrm>
           <a:prstGeom prst="rect">
             <a:avLst/>
@@ -6188,7 +6420,7 @@
               </a:tabLst>
             </a:pPr>
             <a:r>
-              <a:rPr b="0" lang="en-US" sz="1300" spc="-1" strike="noStrike">
+              <a:rPr b="0" lang="es-ES" sz="1300" spc="-1" strike="noStrike">
                 <a:solidFill>
                   <a:srgbClr val="1b2733"/>
                 </a:solidFill>
@@ -6215,7 +6447,7 @@
         <p:spPr>
           <a:xfrm>
             <a:off x="7797960" y="3537720"/>
-            <a:ext cx="3688560" cy="238320"/>
+            <a:ext cx="3687480" cy="237240"/>
           </a:xfrm>
           <a:prstGeom prst="rect">
             <a:avLst/>
@@ -6245,7 +6477,7 @@
               </a:tabLst>
             </a:pPr>
             <a:r>
-              <a:rPr b="0" lang="en-US" sz="1200" spc="-1" strike="noStrike">
+              <a:rPr b="0" lang="es-ES" sz="1200" spc="-1" strike="noStrike">
                 <a:solidFill>
                   <a:srgbClr val="5b6672"/>
                 </a:solidFill>
@@ -6272,7 +6504,7 @@
         <p:spPr>
           <a:xfrm>
             <a:off x="7797960" y="3903480"/>
-            <a:ext cx="3580920" cy="680040"/>
+            <a:ext cx="3579840" cy="678960"/>
           </a:xfrm>
           <a:prstGeom prst="roundRect">
             <a:avLst>
@@ -6306,7 +6538,7 @@
               </a:tabLst>
             </a:pPr>
             <a:r>
-              <a:rPr b="0" lang="en-US" sz="1200" spc="-1" strike="noStrike">
+              <a:rPr b="0" lang="es-ES" sz="1200" spc="-1" strike="noStrike">
                 <a:solidFill>
                   <a:srgbClr val="e8eef4"/>
                 </a:solidFill>
@@ -6333,7 +6565,7 @@
         <p:spPr>
           <a:xfrm>
             <a:off x="7797960" y="4736520"/>
-            <a:ext cx="3688560" cy="238320"/>
+            <a:ext cx="3687480" cy="237240"/>
           </a:xfrm>
           <a:prstGeom prst="rect">
             <a:avLst/>
@@ -6363,7 +6595,7 @@
               </a:tabLst>
             </a:pPr>
             <a:r>
-              <a:rPr b="1" lang="en-US" sz="1200" spc="-1" strike="noStrike">
+              <a:rPr b="1" lang="es-ES" sz="1200" spc="-1" strike="noStrike">
                 <a:solidFill>
                   <a:srgbClr val="b4530f"/>
                 </a:solidFill>
@@ -6390,7 +6622,7 @@
         <p:spPr>
           <a:xfrm>
             <a:off x="812880" y="6238440"/>
-            <a:ext cx="10883160" cy="238320"/>
+            <a:ext cx="10882080" cy="237240"/>
           </a:xfrm>
           <a:prstGeom prst="rect">
             <a:avLst/>
@@ -6420,7 +6652,7 @@
               </a:tabLst>
             </a:pPr>
             <a:r>
-              <a:rPr b="0" lang="en-US" sz="1200" spc="-1" strike="noStrike">
+              <a:rPr b="0" lang="es-ES" sz="1200" spc="-1" strike="noStrike">
                 <a:solidFill>
                   <a:srgbClr val="5b6672"/>
                 </a:solidFill>
@@ -6484,7 +6716,7 @@
         <p:spPr>
           <a:xfrm>
             <a:off x="812880" y="812880"/>
-            <a:ext cx="10883160" cy="273960"/>
+            <a:ext cx="10882080" cy="272880"/>
           </a:xfrm>
           <a:prstGeom prst="rect">
             <a:avLst/>
@@ -6514,7 +6746,7 @@
               </a:tabLst>
             </a:pPr>
             <a:r>
-              <a:rPr b="1" lang="en-US" sz="1400" spc="-1" strike="noStrike">
+              <a:rPr b="1" lang="es-ES" sz="1400" spc="-1" strike="noStrike">
                 <a:solidFill>
                   <a:srgbClr val="b4530f"/>
                 </a:solidFill>
@@ -6545,7 +6777,7 @@
         <p:spPr>
           <a:xfrm>
             <a:off x="812880" y="1290240"/>
-            <a:ext cx="10883160" cy="500040"/>
+            <a:ext cx="10882080" cy="498960"/>
           </a:xfrm>
           <a:prstGeom prst="rect">
             <a:avLst/>
@@ -6564,24 +6796,30 @@
               <a:lnSpc>
                 <a:spcPts val="3739"/>
               </a:lnSpc>
+              <a:spcBef>
+                <a:spcPts val="1191"/>
+              </a:spcBef>
+              <a:spcAft>
+                <a:spcPts val="992"/>
+              </a:spcAft>
               <a:buNone/>
               <a:tabLst>
                 <a:tab algn="l" pos="0"/>
               </a:tabLst>
             </a:pPr>
             <a:r>
-              <a:rPr b="1" lang="en-US" sz="3400" spc="-1" strike="noStrike">
+              <a:rPr b="1" lang="es-ES" sz="3400" spc="-1" strike="noStrike">
                 <a:solidFill>
                   <a:srgbClr val="0f2a44"/>
                 </a:solidFill>
                 <a:latin typeface="Georgia"/>
                 <a:ea typeface="Georgia"/>
               </a:rPr>
-              <a:t>Sinaplot</a:t>
+              <a:t>Sinaplot (Gráfico de distribución de puntos)</a:t>
             </a:r>
             <a:endParaRPr b="0" lang="es-ES" sz="3400" spc="-1" strike="noStrike">
               <a:solidFill>
-                <a:schemeClr val="dk1"/>
+                <a:srgbClr val="000000"/>
               </a:solidFill>
               <a:latin typeface="Arial"/>
             </a:endParaRPr>
@@ -6597,7 +6835,7 @@
         <p:spPr>
           <a:xfrm>
             <a:off x="816120" y="1996920"/>
-            <a:ext cx="3380040" cy="2463840"/>
+            <a:ext cx="3378960" cy="2462760"/>
           </a:xfrm>
           <a:prstGeom prst="roundRect">
             <a:avLst>
@@ -6625,6 +6863,11 @@
             <a:noAutofit/>
           </a:bodyPr>
           <a:p>
+            <a:pPr>
+              <a:lnSpc>
+                <a:spcPct val="100000"/>
+              </a:lnSpc>
+            </a:pPr>
             <a:endParaRPr b="0" lang="es-ES" sz="1800" spc="-1" strike="noStrike">
               <a:solidFill>
                 <a:srgbClr val="000000"/>
@@ -6643,7 +6886,7 @@
         <p:spPr>
           <a:xfrm>
             <a:off x="1075320" y="2256120"/>
-            <a:ext cx="2947320" cy="268920"/>
+            <a:ext cx="2946240" cy="267840"/>
           </a:xfrm>
           <a:prstGeom prst="rect">
             <a:avLst/>
@@ -6673,7 +6916,7 @@
               </a:tabLst>
             </a:pPr>
             <a:r>
-              <a:rPr b="1" lang="en-US" sz="1600" spc="-1" strike="noStrike">
+              <a:rPr b="1" lang="es-ES" sz="1600" spc="-1" strike="noStrike">
                 <a:solidFill>
                   <a:srgbClr val="0b5394"/>
                 </a:solidFill>
@@ -6700,7 +6943,7 @@
         <p:spPr>
           <a:xfrm>
             <a:off x="1075320" y="2601720"/>
-            <a:ext cx="2947320" cy="1358640"/>
+            <a:ext cx="2946240" cy="1357560"/>
           </a:xfrm>
           <a:prstGeom prst="rect">
             <a:avLst/>
@@ -6730,7 +6973,7 @@
               </a:tabLst>
             </a:pPr>
             <a:r>
-              <a:rPr b="0" lang="en-US" sz="1500" spc="-1" strike="noStrike">
+              <a:rPr b="0" lang="es-ES" sz="1500" spc="-1" strike="noStrike">
                 <a:solidFill>
                   <a:srgbClr val="1b2733"/>
                 </a:solidFill>
@@ -6757,7 +7000,7 @@
         <p:spPr>
           <a:xfrm>
             <a:off x="4405680" y="1996920"/>
-            <a:ext cx="3380040" cy="2463840"/>
+            <a:ext cx="3378960" cy="2462760"/>
           </a:xfrm>
           <a:prstGeom prst="roundRect">
             <a:avLst>
@@ -6785,6 +7028,11 @@
             <a:noAutofit/>
           </a:bodyPr>
           <a:p>
+            <a:pPr>
+              <a:lnSpc>
+                <a:spcPct val="100000"/>
+              </a:lnSpc>
+            </a:pPr>
             <a:endParaRPr b="0" lang="es-ES" sz="1800" spc="-1" strike="noStrike">
               <a:solidFill>
                 <a:srgbClr val="000000"/>
@@ -6803,7 +7051,7 @@
         <p:spPr>
           <a:xfrm>
             <a:off x="4665240" y="2256120"/>
-            <a:ext cx="2947320" cy="268920"/>
+            <a:ext cx="2946240" cy="267840"/>
           </a:xfrm>
           <a:prstGeom prst="rect">
             <a:avLst/>
@@ -6833,7 +7081,7 @@
               </a:tabLst>
             </a:pPr>
             <a:r>
-              <a:rPr b="1" lang="en-US" sz="1600" spc="-1" strike="noStrike">
+              <a:rPr b="1" lang="es-ES" sz="1600" spc="-1" strike="noStrike">
                 <a:solidFill>
                   <a:srgbClr val="b4530f"/>
                 </a:solidFill>
@@ -6860,7 +7108,7 @@
         <p:spPr>
           <a:xfrm>
             <a:off x="4665240" y="2601720"/>
-            <a:ext cx="2947320" cy="1091880"/>
+            <a:ext cx="2946240" cy="1090800"/>
           </a:xfrm>
           <a:prstGeom prst="rect">
             <a:avLst/>
@@ -6890,7 +7138,7 @@
               </a:tabLst>
             </a:pPr>
             <a:r>
-              <a:rPr b="0" lang="en-US" sz="1500" spc="-1" strike="noStrike">
+              <a:rPr b="0" lang="es-ES" sz="1500" spc="-1" strike="noStrike">
                 <a:solidFill>
                   <a:srgbClr val="1b2733"/>
                 </a:solidFill>
@@ -6917,7 +7165,7 @@
         <p:spPr>
           <a:xfrm>
             <a:off x="7995600" y="1996920"/>
-            <a:ext cx="3380040" cy="2463840"/>
+            <a:ext cx="3378960" cy="2462760"/>
           </a:xfrm>
           <a:prstGeom prst="roundRect">
             <a:avLst>
@@ -6945,6 +7193,11 @@
             <a:noAutofit/>
           </a:bodyPr>
           <a:p>
+            <a:pPr>
+              <a:lnSpc>
+                <a:spcPct val="100000"/>
+              </a:lnSpc>
+            </a:pPr>
             <a:endParaRPr b="0" lang="es-ES" sz="1800" spc="-1" strike="noStrike">
               <a:solidFill>
                 <a:srgbClr val="000000"/>
@@ -6963,7 +7216,7 @@
         <p:spPr>
           <a:xfrm>
             <a:off x="8255160" y="2256120"/>
-            <a:ext cx="2947320" cy="268920"/>
+            <a:ext cx="2946240" cy="267840"/>
           </a:xfrm>
           <a:prstGeom prst="rect">
             <a:avLst/>
@@ -6993,7 +7246,7 @@
               </a:tabLst>
             </a:pPr>
             <a:r>
-              <a:rPr b="1" lang="en-US" sz="1600" spc="-1" strike="noStrike">
+              <a:rPr b="1" lang="es-ES" sz="1600" spc="-1" strike="noStrike">
                 <a:solidFill>
                   <a:srgbClr val="0f2a44"/>
                 </a:solidFill>
@@ -7020,7 +7273,7 @@
         <p:spPr>
           <a:xfrm>
             <a:off x="8255160" y="2601720"/>
-            <a:ext cx="2947320" cy="1625400"/>
+            <a:ext cx="2946240" cy="1624320"/>
           </a:xfrm>
           <a:prstGeom prst="rect">
             <a:avLst/>
@@ -7050,7 +7303,7 @@
               </a:tabLst>
             </a:pPr>
             <a:r>
-              <a:rPr b="0" lang="en-US" sz="1500" spc="-1" strike="noStrike">
+              <a:rPr b="0" lang="es-ES" sz="1500" spc="-1" strike="noStrike">
                 <a:solidFill>
                   <a:srgbClr val="1b2733"/>
                 </a:solidFill>
@@ -7077,7 +7330,7 @@
         <p:spPr>
           <a:xfrm>
             <a:off x="812880" y="6238440"/>
-            <a:ext cx="10883160" cy="238320"/>
+            <a:ext cx="10882080" cy="237240"/>
           </a:xfrm>
           <a:prstGeom prst="rect">
             <a:avLst/>
@@ -7107,7 +7360,7 @@
               </a:tabLst>
             </a:pPr>
             <a:r>
-              <a:rPr b="0" lang="en-US" sz="1200" spc="-1" strike="noStrike">
+              <a:rPr b="0" lang="es-ES" sz="1200" spc="-1" strike="noStrike">
                 <a:solidFill>
                   <a:srgbClr val="5b6672"/>
                 </a:solidFill>
@@ -7175,7 +7428,7 @@
         <p:spPr>
           <a:xfrm>
             <a:off x="812880" y="812880"/>
-            <a:ext cx="10883160" cy="751320"/>
+            <a:ext cx="10882080" cy="750240"/>
           </a:xfrm>
           <a:prstGeom prst="rect">
             <a:avLst/>
@@ -7200,7 +7453,7 @@
               </a:tabLst>
             </a:pPr>
             <a:r>
-              <a:rPr b="1" lang="en-US" sz="2600" spc="-1" strike="noStrike">
+              <a:rPr b="1" lang="es-ES" sz="2600" spc="-1" strike="noStrike">
                 <a:solidFill>
                   <a:srgbClr val="0f2a44"/>
                 </a:solidFill>
@@ -7211,7 +7464,7 @@
             </a:r>
             <a:endParaRPr b="0" lang="es-ES" sz="2600" spc="-1" strike="noStrike">
               <a:solidFill>
-                <a:schemeClr val="dk1"/>
+                <a:srgbClr val="000000"/>
               </a:solidFill>
               <a:latin typeface="Arial"/>
             </a:endParaRPr>
@@ -7227,7 +7480,7 @@
         <p:spPr>
           <a:xfrm>
             <a:off x="812880" y="1767600"/>
-            <a:ext cx="6730560" cy="3472920"/>
+            <a:ext cx="6729480" cy="3471840"/>
           </a:xfrm>
           <a:prstGeom prst="roundRect">
             <a:avLst>
@@ -7252,6 +7505,11 @@
             <a:noAutofit/>
           </a:bodyPr>
           <a:p>
+            <a:pPr>
+              <a:lnSpc>
+                <a:spcPct val="100000"/>
+              </a:lnSpc>
+            </a:pPr>
             <a:endParaRPr b="0" lang="es-ES" sz="1800" spc="-1" strike="noStrike">
               <a:solidFill>
                 <a:srgbClr val="000000"/>
@@ -7270,7 +7528,7 @@
         <p:spPr>
           <a:xfrm>
             <a:off x="819000" y="1774080"/>
-            <a:ext cx="6717960" cy="3460320"/>
+            <a:ext cx="6716880" cy="3459240"/>
           </a:xfrm>
           <a:prstGeom prst="roundRect">
             <a:avLst>
@@ -7297,6 +7555,11 @@
             <a:noAutofit/>
           </a:bodyPr>
           <a:p>
+            <a:pPr>
+              <a:lnSpc>
+                <a:spcPct val="100000"/>
+              </a:lnSpc>
+            </a:pPr>
             <a:endParaRPr b="0" lang="es-ES" sz="1800" spc="-1" strike="noStrike">
               <a:solidFill>
                 <a:srgbClr val="000000"/>
@@ -7315,7 +7578,7 @@
         <p:spPr>
           <a:xfrm>
             <a:off x="816120" y="1770840"/>
-            <a:ext cx="6724440" cy="3466800"/>
+            <a:ext cx="6723360" cy="3465720"/>
           </a:xfrm>
           <a:prstGeom prst="roundRect">
             <a:avLst>
@@ -7341,6 +7604,11 @@
             <a:noAutofit/>
           </a:bodyPr>
           <a:p>
+            <a:pPr>
+              <a:lnSpc>
+                <a:spcPct val="100000"/>
+              </a:lnSpc>
+            </a:pPr>
             <a:endParaRPr b="0" lang="es-ES" sz="1800" spc="-1" strike="noStrike">
               <a:solidFill>
                 <a:srgbClr val="000000"/>
@@ -7359,7 +7627,7 @@
         <p:spPr>
           <a:xfrm>
             <a:off x="7797960" y="1767600"/>
-            <a:ext cx="3688560" cy="1642680"/>
+            <a:ext cx="3687480" cy="1641600"/>
           </a:xfrm>
           <a:prstGeom prst="rect">
             <a:avLst/>
@@ -7389,7 +7657,7 @@
               </a:tabLst>
             </a:pPr>
             <a:r>
-              <a:rPr b="0" lang="en-US" sz="1300" spc="-1" strike="noStrike">
+              <a:rPr b="0" lang="es-ES" sz="1300" spc="-1" strike="noStrike">
                 <a:solidFill>
                   <a:srgbClr val="1b2733"/>
                 </a:solidFill>
@@ -7416,7 +7684,7 @@
         <p:spPr>
           <a:xfrm>
             <a:off x="7797960" y="3537720"/>
-            <a:ext cx="3688560" cy="238320"/>
+            <a:ext cx="3687480" cy="237240"/>
           </a:xfrm>
           <a:prstGeom prst="rect">
             <a:avLst/>
@@ -7446,7 +7714,7 @@
               </a:tabLst>
             </a:pPr>
             <a:r>
-              <a:rPr b="0" lang="en-US" sz="1200" spc="-1" strike="noStrike">
+              <a:rPr b="0" lang="es-ES" sz="1200" spc="-1" strike="noStrike">
                 <a:solidFill>
                   <a:srgbClr val="5b6672"/>
                 </a:solidFill>
@@ -7473,7 +7741,7 @@
         <p:spPr>
           <a:xfrm>
             <a:off x="7797960" y="3903480"/>
-            <a:ext cx="3580920" cy="680040"/>
+            <a:ext cx="3579840" cy="678960"/>
           </a:xfrm>
           <a:prstGeom prst="roundRect">
             <a:avLst>
@@ -7507,7 +7775,7 @@
               </a:tabLst>
             </a:pPr>
             <a:r>
-              <a:rPr b="0" lang="en-US" sz="1200" spc="-1" strike="noStrike">
+              <a:rPr b="0" lang="es-ES" sz="1200" spc="-1" strike="noStrike">
                 <a:solidFill>
                   <a:srgbClr val="e8eef4"/>
                 </a:solidFill>
@@ -7534,7 +7802,7 @@
         <p:spPr>
           <a:xfrm>
             <a:off x="7797960" y="4736520"/>
-            <a:ext cx="3688560" cy="238320"/>
+            <a:ext cx="3687480" cy="237240"/>
           </a:xfrm>
           <a:prstGeom prst="rect">
             <a:avLst/>
@@ -7564,7 +7832,7 @@
               </a:tabLst>
             </a:pPr>
             <a:r>
-              <a:rPr b="1" lang="en-US" sz="1200" spc="-1" strike="noStrike">
+              <a:rPr b="1" lang="es-ES" sz="1200" spc="-1" strike="noStrike">
                 <a:solidFill>
                   <a:srgbClr val="b4530f"/>
                 </a:solidFill>
@@ -7591,7 +7859,7 @@
         <p:spPr>
           <a:xfrm>
             <a:off x="812880" y="6238440"/>
-            <a:ext cx="10883160" cy="238320"/>
+            <a:ext cx="10882080" cy="237240"/>
           </a:xfrm>
           <a:prstGeom prst="rect">
             <a:avLst/>
@@ -7621,7 +7889,7 @@
               </a:tabLst>
             </a:pPr>
             <a:r>
-              <a:rPr b="0" lang="en-US" sz="1200" spc="-1" strike="noStrike">
+              <a:rPr b="0" lang="es-ES" sz="1200" spc="-1" strike="noStrike">
                 <a:solidFill>
                   <a:srgbClr val="5b6672"/>
                 </a:solidFill>
@@ -7685,7 +7953,7 @@
         <p:spPr>
           <a:xfrm>
             <a:off x="812880" y="812880"/>
-            <a:ext cx="10883160" cy="273960"/>
+            <a:ext cx="10882080" cy="272880"/>
           </a:xfrm>
           <a:prstGeom prst="rect">
             <a:avLst/>
@@ -7715,7 +7983,7 @@
               </a:tabLst>
             </a:pPr>
             <a:r>
-              <a:rPr b="1" lang="en-US" sz="1400" spc="-1" strike="noStrike">
+              <a:rPr b="1" lang="es-ES" sz="1400" spc="-1" strike="noStrike">
                 <a:solidFill>
                   <a:srgbClr val="b4530f"/>
                 </a:solidFill>
@@ -7746,7 +8014,7 @@
         <p:spPr>
           <a:xfrm>
             <a:off x="812880" y="1290240"/>
-            <a:ext cx="10883160" cy="500040"/>
+            <a:ext cx="10882080" cy="498960"/>
           </a:xfrm>
           <a:prstGeom prst="rect">
             <a:avLst/>
@@ -7758,31 +8026,37 @@
         </p:spPr>
         <p:txBody>
           <a:bodyPr lIns="0" rIns="0" tIns="0" bIns="0" anchor="t">
-            <a:normAutofit/>
+            <a:normAutofit fontScale="50000"/>
           </a:bodyPr>
           <a:p>
             <a:pPr indent="0" defTabSz="914400">
               <a:lnSpc>
                 <a:spcPts val="3739"/>
               </a:lnSpc>
+              <a:spcBef>
+                <a:spcPts val="1191"/>
+              </a:spcBef>
+              <a:spcAft>
+                <a:spcPts val="992"/>
+              </a:spcAft>
               <a:buNone/>
               <a:tabLst>
                 <a:tab algn="l" pos="0"/>
               </a:tabLst>
             </a:pPr>
             <a:r>
-              <a:rPr b="1" lang="en-US" sz="3400" spc="-1" strike="noStrike">
+              <a:rPr b="1" lang="es-ES" sz="3400" spc="-1" strike="noStrike">
                 <a:solidFill>
                   <a:srgbClr val="0f2a44"/>
                 </a:solidFill>
                 <a:latin typeface="Georgia"/>
                 <a:ea typeface="Georgia"/>
               </a:rPr>
-              <a:t>Boxenplot (Letter-Value Plot)</a:t>
+              <a:t>Boxenplot (Letter-Value Plot o Gráfico de cajas por niveles de cuantiles)</a:t>
             </a:r>
             <a:endParaRPr b="0" lang="es-ES" sz="3400" spc="-1" strike="noStrike">
               <a:solidFill>
-                <a:schemeClr val="dk1"/>
+                <a:srgbClr val="000000"/>
               </a:solidFill>
               <a:latin typeface="Arial"/>
             </a:endParaRPr>
@@ -7798,7 +8072,7 @@
         <p:spPr>
           <a:xfrm>
             <a:off x="816120" y="1996920"/>
-            <a:ext cx="3380040" cy="2730600"/>
+            <a:ext cx="3378960" cy="2729520"/>
           </a:xfrm>
           <a:prstGeom prst="roundRect">
             <a:avLst>
@@ -7826,6 +8100,11 @@
             <a:noAutofit/>
           </a:bodyPr>
           <a:p>
+            <a:pPr>
+              <a:lnSpc>
+                <a:spcPct val="100000"/>
+              </a:lnSpc>
+            </a:pPr>
             <a:endParaRPr b="0" lang="es-ES" sz="1800" spc="-1" strike="noStrike">
               <a:solidFill>
                 <a:srgbClr val="000000"/>
@@ -7844,7 +8123,7 @@
         <p:spPr>
           <a:xfrm>
             <a:off x="1075320" y="2256120"/>
-            <a:ext cx="2947320" cy="268920"/>
+            <a:ext cx="2946240" cy="267840"/>
           </a:xfrm>
           <a:prstGeom prst="rect">
             <a:avLst/>
@@ -7874,7 +8153,7 @@
               </a:tabLst>
             </a:pPr>
             <a:r>
-              <a:rPr b="1" lang="en-US" sz="1600" spc="-1" strike="noStrike">
+              <a:rPr b="1" lang="es-ES" sz="1600" spc="-1" strike="noStrike">
                 <a:solidFill>
                   <a:srgbClr val="0b5394"/>
                 </a:solidFill>
@@ -7901,7 +8180,7 @@
         <p:spPr>
           <a:xfrm>
             <a:off x="1075320" y="2601720"/>
-            <a:ext cx="2947320" cy="1358640"/>
+            <a:ext cx="2946240" cy="1357560"/>
           </a:xfrm>
           <a:prstGeom prst="rect">
             <a:avLst/>
@@ -7931,7 +8210,7 @@
               </a:tabLst>
             </a:pPr>
             <a:r>
-              <a:rPr b="0" lang="en-US" sz="1500" spc="-1" strike="noStrike">
+              <a:rPr b="0" lang="es-ES" sz="1500" spc="-1" strike="noStrike">
                 <a:solidFill>
                   <a:srgbClr val="1b2733"/>
                 </a:solidFill>
@@ -7958,7 +8237,7 @@
         <p:spPr>
           <a:xfrm>
             <a:off x="4405680" y="1996920"/>
-            <a:ext cx="3380040" cy="2730600"/>
+            <a:ext cx="3378960" cy="2729520"/>
           </a:xfrm>
           <a:prstGeom prst="roundRect">
             <a:avLst>
@@ -7986,6 +8265,11 @@
             <a:noAutofit/>
           </a:bodyPr>
           <a:p>
+            <a:pPr>
+              <a:lnSpc>
+                <a:spcPct val="100000"/>
+              </a:lnSpc>
+            </a:pPr>
             <a:endParaRPr b="0" lang="es-ES" sz="1800" spc="-1" strike="noStrike">
               <a:solidFill>
                 <a:srgbClr val="000000"/>
@@ -8004,7 +8288,7 @@
         <p:spPr>
           <a:xfrm>
             <a:off x="4665240" y="2256120"/>
-            <a:ext cx="2947320" cy="268920"/>
+            <a:ext cx="2946240" cy="267840"/>
           </a:xfrm>
           <a:prstGeom prst="rect">
             <a:avLst/>
@@ -8034,7 +8318,7 @@
               </a:tabLst>
             </a:pPr>
             <a:r>
-              <a:rPr b="1" lang="en-US" sz="1600" spc="-1" strike="noStrike">
+              <a:rPr b="1" lang="es-ES" sz="1600" spc="-1" strike="noStrike">
                 <a:solidFill>
                   <a:srgbClr val="b4530f"/>
                 </a:solidFill>
@@ -8061,7 +8345,7 @@
         <p:spPr>
           <a:xfrm>
             <a:off x="4665240" y="2601720"/>
-            <a:ext cx="2947320" cy="1091880"/>
+            <a:ext cx="2946240" cy="1090800"/>
           </a:xfrm>
           <a:prstGeom prst="rect">
             <a:avLst/>
@@ -8091,7 +8375,7 @@
               </a:tabLst>
             </a:pPr>
             <a:r>
-              <a:rPr b="0" lang="en-US" sz="1500" spc="-1" strike="noStrike">
+              <a:rPr b="0" lang="es-ES" sz="1500" spc="-1" strike="noStrike">
                 <a:solidFill>
                   <a:srgbClr val="1b2733"/>
                 </a:solidFill>
@@ -8118,7 +8402,7 @@
         <p:spPr>
           <a:xfrm>
             <a:off x="7995600" y="1996920"/>
-            <a:ext cx="3380040" cy="2730600"/>
+            <a:ext cx="3378960" cy="2729520"/>
           </a:xfrm>
           <a:prstGeom prst="roundRect">
             <a:avLst>
@@ -8146,6 +8430,11 @@
             <a:noAutofit/>
           </a:bodyPr>
           <a:p>
+            <a:pPr>
+              <a:lnSpc>
+                <a:spcPct val="100000"/>
+              </a:lnSpc>
+            </a:pPr>
             <a:endParaRPr b="0" lang="es-ES" sz="1800" spc="-1" strike="noStrike">
               <a:solidFill>
                 <a:srgbClr val="000000"/>
@@ -8164,7 +8453,7 @@
         <p:spPr>
           <a:xfrm>
             <a:off x="8255160" y="2256120"/>
-            <a:ext cx="2947320" cy="268920"/>
+            <a:ext cx="2946240" cy="267840"/>
           </a:xfrm>
           <a:prstGeom prst="rect">
             <a:avLst/>
@@ -8194,7 +8483,7 @@
               </a:tabLst>
             </a:pPr>
             <a:r>
-              <a:rPr b="1" lang="en-US" sz="1600" spc="-1" strike="noStrike">
+              <a:rPr b="1" lang="es-ES" sz="1600" spc="-1" strike="noStrike">
                 <a:solidFill>
                   <a:srgbClr val="0f2a44"/>
                 </a:solidFill>
@@ -8221,7 +8510,7 @@
         <p:spPr>
           <a:xfrm>
             <a:off x="8255160" y="2601720"/>
-            <a:ext cx="2947320" cy="1891800"/>
+            <a:ext cx="2946240" cy="1890720"/>
           </a:xfrm>
           <a:prstGeom prst="rect">
             <a:avLst/>
@@ -8251,7 +8540,7 @@
               </a:tabLst>
             </a:pPr>
             <a:r>
-              <a:rPr b="0" lang="en-US" sz="1500" spc="-1" strike="noStrike">
+              <a:rPr b="0" lang="es-ES" sz="1500" spc="-1" strike="noStrike">
                 <a:solidFill>
                   <a:srgbClr val="1b2733"/>
                 </a:solidFill>
@@ -8278,7 +8567,7 @@
         <p:spPr>
           <a:xfrm>
             <a:off x="812880" y="6238440"/>
-            <a:ext cx="10883160" cy="238320"/>
+            <a:ext cx="10882080" cy="237240"/>
           </a:xfrm>
           <a:prstGeom prst="rect">
             <a:avLst/>
@@ -8308,7 +8597,7 @@
               </a:tabLst>
             </a:pPr>
             <a:r>
-              <a:rPr b="0" lang="en-US" sz="1200" spc="-1" strike="noStrike">
+              <a:rPr b="0" lang="es-ES" sz="1200" spc="-1" strike="noStrike">
                 <a:solidFill>
                   <a:srgbClr val="5b6672"/>
                 </a:solidFill>
@@ -8376,7 +8665,7 @@
         <p:spPr>
           <a:xfrm>
             <a:off x="812880" y="812880"/>
-            <a:ext cx="10883160" cy="751320"/>
+            <a:ext cx="10882080" cy="750240"/>
           </a:xfrm>
           <a:prstGeom prst="rect">
             <a:avLst/>
@@ -8401,7 +8690,7 @@
               </a:tabLst>
             </a:pPr>
             <a:r>
-              <a:rPr b="1" lang="en-US" sz="2600" spc="-1" strike="noStrike">
+              <a:rPr b="1" lang="es-ES" sz="2600" spc="-1" strike="noStrike">
                 <a:solidFill>
                   <a:srgbClr val="0f2a44"/>
                 </a:solidFill>
@@ -8412,7 +8701,7 @@
             </a:r>
             <a:endParaRPr b="0" lang="es-ES" sz="2600" spc="-1" strike="noStrike">
               <a:solidFill>
-                <a:schemeClr val="dk1"/>
+                <a:srgbClr val="000000"/>
               </a:solidFill>
               <a:latin typeface="Arial"/>
             </a:endParaRPr>
@@ -8428,7 +8717,7 @@
         <p:spPr>
           <a:xfrm>
             <a:off x="812880" y="1767600"/>
-            <a:ext cx="6730560" cy="3314520"/>
+            <a:ext cx="6729480" cy="3313440"/>
           </a:xfrm>
           <a:prstGeom prst="roundRect">
             <a:avLst>
@@ -8453,6 +8742,11 @@
             <a:noAutofit/>
           </a:bodyPr>
           <a:p>
+            <a:pPr>
+              <a:lnSpc>
+                <a:spcPct val="100000"/>
+              </a:lnSpc>
+            </a:pPr>
             <a:endParaRPr b="0" lang="es-ES" sz="1800" spc="-1" strike="noStrike">
               <a:solidFill>
                 <a:srgbClr val="000000"/>
@@ -8471,7 +8765,7 @@
         <p:spPr>
           <a:xfrm>
             <a:off x="819000" y="1774080"/>
-            <a:ext cx="6717960" cy="3301560"/>
+            <a:ext cx="6716880" cy="3300480"/>
           </a:xfrm>
           <a:prstGeom prst="roundRect">
             <a:avLst>
@@ -8498,6 +8792,11 @@
             <a:noAutofit/>
           </a:bodyPr>
           <a:p>
+            <a:pPr>
+              <a:lnSpc>
+                <a:spcPct val="100000"/>
+              </a:lnSpc>
+            </a:pPr>
             <a:endParaRPr b="0" lang="es-ES" sz="1800" spc="-1" strike="noStrike">
               <a:solidFill>
                 <a:srgbClr val="000000"/>
@@ -8516,7 +8815,7 @@
         <p:spPr>
           <a:xfrm>
             <a:off x="816120" y="1770840"/>
-            <a:ext cx="6724440" cy="3308040"/>
+            <a:ext cx="6723360" cy="3306960"/>
           </a:xfrm>
           <a:prstGeom prst="roundRect">
             <a:avLst>
@@ -8542,6 +8841,11 @@
             <a:noAutofit/>
           </a:bodyPr>
           <a:p>
+            <a:pPr>
+              <a:lnSpc>
+                <a:spcPct val="100000"/>
+              </a:lnSpc>
+            </a:pPr>
             <a:endParaRPr b="0" lang="es-ES" sz="1800" spc="-1" strike="noStrike">
               <a:solidFill>
                 <a:srgbClr val="000000"/>
@@ -8560,7 +8864,7 @@
         <p:spPr>
           <a:xfrm>
             <a:off x="7797960" y="1767600"/>
-            <a:ext cx="3688560" cy="1642680"/>
+            <a:ext cx="3687480" cy="1641600"/>
           </a:xfrm>
           <a:prstGeom prst="rect">
             <a:avLst/>
@@ -8590,7 +8894,7 @@
               </a:tabLst>
             </a:pPr>
             <a:r>
-              <a:rPr b="0" lang="en-US" sz="1300" spc="-1" strike="noStrike">
+              <a:rPr b="0" lang="es-ES" sz="1300" spc="-1" strike="noStrike">
                 <a:solidFill>
                   <a:srgbClr val="1b2733"/>
                 </a:solidFill>
@@ -8617,7 +8921,7 @@
         <p:spPr>
           <a:xfrm>
             <a:off x="7797960" y="3537720"/>
-            <a:ext cx="3688560" cy="238320"/>
+            <a:ext cx="3687480" cy="237240"/>
           </a:xfrm>
           <a:prstGeom prst="rect">
             <a:avLst/>
@@ -8647,7 +8951,7 @@
               </a:tabLst>
             </a:pPr>
             <a:r>
-              <a:rPr b="0" lang="en-US" sz="1200" spc="-1" strike="noStrike">
+              <a:rPr b="0" lang="es-ES" sz="1200" spc="-1" strike="noStrike">
                 <a:solidFill>
                   <a:srgbClr val="5b6672"/>
                 </a:solidFill>
@@ -8674,7 +8978,7 @@
         <p:spPr>
           <a:xfrm>
             <a:off x="7797960" y="3903480"/>
-            <a:ext cx="3580920" cy="680040"/>
+            <a:ext cx="3579840" cy="678960"/>
           </a:xfrm>
           <a:prstGeom prst="roundRect">
             <a:avLst>
@@ -8708,7 +9012,7 @@
               </a:tabLst>
             </a:pPr>
             <a:r>
-              <a:rPr b="0" lang="en-US" sz="1200" spc="-1" strike="noStrike">
+              <a:rPr b="0" lang="es-ES" sz="1200" spc="-1" strike="noStrike">
                 <a:solidFill>
                   <a:srgbClr val="e8eef4"/>
                 </a:solidFill>
@@ -8735,7 +9039,7 @@
         <p:spPr>
           <a:xfrm>
             <a:off x="7797960" y="4736520"/>
-            <a:ext cx="3688560" cy="238320"/>
+            <a:ext cx="3687480" cy="237240"/>
           </a:xfrm>
           <a:prstGeom prst="rect">
             <a:avLst/>
@@ -8765,7 +9069,7 @@
               </a:tabLst>
             </a:pPr>
             <a:r>
-              <a:rPr b="1" lang="en-US" sz="1200" spc="-1" strike="noStrike">
+              <a:rPr b="1" lang="es-ES" sz="1200" spc="-1" strike="noStrike">
                 <a:solidFill>
                   <a:srgbClr val="b4530f"/>
                 </a:solidFill>
@@ -8792,7 +9096,7 @@
         <p:spPr>
           <a:xfrm>
             <a:off x="812880" y="6238440"/>
-            <a:ext cx="10883160" cy="238320"/>
+            <a:ext cx="10882080" cy="237240"/>
           </a:xfrm>
           <a:prstGeom prst="rect">
             <a:avLst/>
@@ -8822,7 +9126,7 @@
               </a:tabLst>
             </a:pPr>
             <a:r>
-              <a:rPr b="0" lang="en-US" sz="1200" spc="-1" strike="noStrike">
+              <a:rPr b="0" lang="es-ES" sz="1200" spc="-1" strike="noStrike">
                 <a:solidFill>
                   <a:srgbClr val="5b6672"/>
                 </a:solidFill>

</xml_diff>